<commit_message>
Replace presentation with 8-slide deck including team details and comprehensive architecture
</commit_message>
<xml_diff>
--- a/BioSpan_AI_Presentation.pptx
+++ b/BioSpan_AI_Presentation.pptx
@@ -8,6 +8,11 @@
     <p:sldId id="256" r:id="rId7"/>
     <p:sldId id="257" r:id="rId8"/>
     <p:sldId id="258" r:id="rId9"/>
+    <p:sldId id="259" r:id="rId10"/>
+    <p:sldId id="260" r:id="rId11"/>
+    <p:sldId id="261" r:id="rId12"/>
+    <p:sldId id="262" r:id="rId13"/>
+    <p:sldId id="263" r:id="rId14"/>
   </p:sldIdLst>
   <p:sldSz cx="12191695" cy="6858000" type="screen4x3"/>
   <p:notesSz cx="6858000" cy="9144000"/>
@@ -3135,6 +3140,262 @@
       </p:sp>
       <p:sp>
         <p:nvSpPr>
+          <p:cNvPr id="3" name="Rounded Rectangle 2"/>
+          <p:cNvSpPr/>
+          <p:nvPr/>
+        </p:nvSpPr>
+        <p:spPr>
+          <a:xfrm>
+            <a:off x="914400" y="731520"/>
+            <a:ext cx="10362895" cy="5394960"/>
+          </a:xfrm>
+          <a:prstGeom prst="roundRect">
+            <a:avLst/>
+          </a:prstGeom>
+          <a:solidFill>
+            <a:srgbClr val="FFFFFF"/>
+          </a:solidFill>
+          <a:ln w="19050">
+            <a:solidFill>
+              <a:srgbClr val="E5DCD0"/>
+            </a:solidFill>
+          </a:ln>
+        </p:spPr>
+        <p:style>
+          <a:lnRef idx="1">
+            <a:schemeClr val="accent1"/>
+          </a:lnRef>
+          <a:fillRef idx="3">
+            <a:schemeClr val="accent1"/>
+          </a:fillRef>
+          <a:effectRef idx="2">
+            <a:schemeClr val="accent1"/>
+          </a:effectRef>
+          <a:fontRef idx="minor">
+            <a:schemeClr val="lt1"/>
+          </a:fontRef>
+        </p:style>
+        <p:txBody>
+          <a:bodyPr rtlCol="0" anchor="ctr" wrap="square" lIns="548640" rIns="548640" tIns="457200"/>
+          <a:lstStyle/>
+          <a:p>
+            <a:pPr algn="ctr">
+              <a:defRPr sz="1100" b="1">
+                <a:solidFill>
+                  <a:srgbClr val="C2652A"/>
+                </a:solidFill>
+                <a:latin typeface="Arial"/>
+              </a:defRPr>
+            </a:pPr>
+            <a:r>
+              <a:t>HEALTHCARE AI &amp; BIOMEDICAL NATURAL LANGUAGE PROCESSING</a:t>
+            </a:r>
+          </a:p>
+          <a:p>
+            <a:pPr>
+              <a:defRPr sz="2600" b="1">
+                <a:solidFill>
+                  <a:srgbClr val="261C14"/>
+                </a:solidFill>
+                <a:latin typeface="Georgia"/>
+              </a:defRPr>
+            </a:pPr>
+            <a:r>
+              <a:t>Project Name: BioSpan AI</a:t>
+            </a:r>
+          </a:p>
+          <a:p>
+            <a:pPr>
+              <a:defRPr sz="1300" b="1">
+                <a:solidFill>
+                  <a:srgbClr val="C2652A"/>
+                </a:solidFill>
+                <a:latin typeface="Arial"/>
+              </a:defRPr>
+            </a:pPr>
+            <a:r>
+              <a:t>Biomedical Named Entity Recognition &amp; Multilingual Healthcare Intelligence System</a:t>
+            </a:r>
+          </a:p>
+          <a:p>
+            <a:pPr>
+              <a:defRPr sz="1100">
+                <a:solidFill>
+                  <a:srgbClr val="6E6359"/>
+                </a:solidFill>
+                <a:latin typeface="Arial"/>
+              </a:defRPr>
+            </a:pPr>
+            <a:r>
+              <a:t>Solving Subword Tokenization Mismatch, Enforcing Constrained Sequence Labeling &amp; Bridging Clinical Jargon Across 13 Indian Languages</a:t>
+            </a:r>
+          </a:p>
+          <a:p>
+            <a:pPr>
+              <a:defRPr sz="800"/>
+            </a:pPr>
+          </a:p>
+          <a:p>
+            <a:pPr>
+              <a:defRPr sz="1500" b="1">
+                <a:solidFill>
+                  <a:srgbClr val="2E7D73"/>
+                </a:solidFill>
+                <a:latin typeface="Arial"/>
+              </a:defRPr>
+            </a:pPr>
+            <a:r>
+              <a:t>Team Name: Neural Nexus</a:t>
+            </a:r>
+          </a:p>
+          <a:p>
+            <a:pPr>
+              <a:defRPr sz="1300" b="1">
+                <a:solidFill>
+                  <a:srgbClr val="261C14"/>
+                </a:solidFill>
+                <a:latin typeface="Arial"/>
+              </a:defRPr>
+            </a:pPr>
+            <a:r>
+              <a:t>Team Members:</a:t>
+            </a:r>
+          </a:p>
+          <a:p>
+            <a:pPr>
+              <a:defRPr sz="1200" b="1">
+                <a:solidFill>
+                  <a:srgbClr val="261C14"/>
+                </a:solidFill>
+                <a:latin typeface="Arial"/>
+              </a:defRPr>
+            </a:pPr>
+            <a:r>
+              <a:t>  •  M. Varshitha : 2420080003</a:t>
+            </a:r>
+          </a:p>
+          <a:p>
+            <a:pPr>
+              <a:defRPr sz="1200" b="1">
+                <a:solidFill>
+                  <a:srgbClr val="261C14"/>
+                </a:solidFill>
+                <a:latin typeface="Arial"/>
+              </a:defRPr>
+            </a:pPr>
+            <a:r>
+              <a:t>  •  B. Jishitha : 2420080048</a:t>
+            </a:r>
+          </a:p>
+          <a:p>
+            <a:pPr>
+              <a:defRPr sz="1200" b="1">
+                <a:solidFill>
+                  <a:srgbClr val="261C14"/>
+                </a:solidFill>
+                <a:latin typeface="Arial"/>
+              </a:defRPr>
+            </a:pPr>
+            <a:r>
+              <a:t>  •  T. Nesta : 2420080070</a:t>
+            </a:r>
+          </a:p>
+          <a:p>
+            <a:pPr>
+              <a:defRPr sz="1200" b="1">
+                <a:solidFill>
+                  <a:srgbClr val="261C14"/>
+                </a:solidFill>
+                <a:latin typeface="Arial"/>
+              </a:defRPr>
+            </a:pPr>
+            <a:r>
+              <a:t>  •  Tannishtha Verma : 2420080098</a:t>
+            </a:r>
+          </a:p>
+          <a:p>
+            <a:pPr>
+              <a:defRPr sz="600"/>
+            </a:pPr>
+          </a:p>
+          <a:p>
+            <a:pPr>
+              <a:defRPr sz="1000">
+                <a:solidFill>
+                  <a:srgbClr val="C2652A"/>
+                </a:solidFill>
+                <a:latin typeface="Arial"/>
+              </a:defRPr>
+            </a:pPr>
+            <a:r>
+              <a:t>Core Pillars: Domain-Specific BioBERT  •  First-Subword (-100) Alignment  •  Deterministic BIO-Sanitizer  •  ICD-10 Linking  •  Multilingual Web Speech</a:t>
+            </a:r>
+          </a:p>
+        </p:txBody>
+      </p:sp>
+    </p:spTree>
+  </p:cSld>
+  <p:clrMapOvr>
+    <a:masterClrMapping/>
+  </p:clrMapOvr>
+</p:sld>
+</file>
+
+<file path=ppt/slides/slide2.xml><?xml version="1.0" encoding="utf-8"?>
+<p:sld xmlns:a="http://schemas.openxmlformats.org/drawingml/2006/main" xmlns:p="http://schemas.openxmlformats.org/presentationml/2006/main" xmlns:r="http://schemas.openxmlformats.org/officeDocument/2006/relationships">
+  <p:cSld>
+    <p:spTree>
+      <p:nvGrpSpPr>
+        <p:cNvPr id="1" name=""/>
+        <p:cNvGrpSpPr/>
+        <p:nvPr/>
+      </p:nvGrpSpPr>
+      <p:grpSpPr/>
+      <p:sp>
+        <p:nvSpPr>
+          <p:cNvPr id="2" name="Rectangle 1"/>
+          <p:cNvSpPr/>
+          <p:nvPr/>
+        </p:nvSpPr>
+        <p:spPr>
+          <a:xfrm>
+            <a:off x="0" y="0"/>
+            <a:ext cx="12191695" cy="6858000"/>
+          </a:xfrm>
+          <a:prstGeom prst="rect">
+            <a:avLst/>
+          </a:prstGeom>
+          <a:solidFill>
+            <a:srgbClr val="FAF5EE"/>
+          </a:solidFill>
+          <a:ln>
+            <a:noFill/>
+          </a:ln>
+        </p:spPr>
+        <p:style>
+          <a:lnRef idx="1">
+            <a:schemeClr val="accent1"/>
+          </a:lnRef>
+          <a:fillRef idx="3">
+            <a:schemeClr val="accent1"/>
+          </a:fillRef>
+          <a:effectRef idx="2">
+            <a:schemeClr val="accent1"/>
+          </a:effectRef>
+          <a:fontRef idx="minor">
+            <a:schemeClr val="lt1"/>
+          </a:fontRef>
+        </p:style>
+        <p:txBody>
+          <a:bodyPr rtlCol="0" anchor="ctr"/>
+          <a:lstStyle/>
+          <a:p>
+            <a:pPr algn="ctr"/>
+          </a:p>
+        </p:txBody>
+      </p:sp>
+      <p:sp>
+        <p:nvSpPr>
           <p:cNvPr id="3" name="TextBox 2"/>
           <p:cNvSpPr txBox="1"/>
           <p:nvPr/>
@@ -3164,7 +3425,7 @@
               </a:defRPr>
             </a:pPr>
             <a:r>
-              <a:t>SLIDE 1 • CORE ENGINEERING &amp; ARCHITECTURE</a:t>
+              <a:t>SLIDE 2 OF 8 • CLINICAL &amp; COMPUTATIONAL PROBLEM</a:t>
             </a:r>
           </a:p>
         </p:txBody>
@@ -3200,7 +3461,7 @@
               </a:defRPr>
             </a:pPr>
             <a:r>
-              <a:t>BioSpan AI: Biomedical NER, Subword Alignment &amp; Clinical Solution</a:t>
+              <a:t>The Problem Statement: Why Biomedical NER Fails Today</a:t>
             </a:r>
           </a:p>
         </p:txBody>
@@ -3236,7 +3497,7 @@
               </a:defRPr>
             </a:pPr>
             <a:r>
-              <a:t>End-to-end framework resolving clinical entity recognition, multi-word boundary loss, and jargon barriers.</a:t>
+              <a:t>Clinical entities are non-trivial multi-word phenotypes where standard general NLP models suffer critical failure modes.</a:t>
             </a:r>
           </a:p>
         </p:txBody>
@@ -3283,14 +3544,14 @@
           <a:lstStyle/>
           <a:p>
             <a:pPr algn="ctr">
-              <a:defRPr sz="1400" b="1">
+              <a:defRPr sz="1300" b="1">
                 <a:solidFill>
                   <a:srgbClr val="B33A3A"/>
                 </a:solidFill>
               </a:defRPr>
             </a:pPr>
             <a:r>
-              <a:t>🚨 Problem Statement</a:t>
+              <a:t>🚨 Multi-Word Entity Boundary Loss</a:t>
             </a:r>
           </a:p>
           <a:p>
@@ -3302,7 +3563,7 @@
               </a:defRPr>
             </a:pPr>
             <a:r>
-              <a:t>• Multi-Word Clinical Entities: </a:t>
+              <a:t>• Composite Phenotypes: </a:t>
             </a:r>
           </a:p>
           <a:p>
@@ -3314,7 +3575,7 @@
               </a:defRPr>
             </a:pPr>
             <a:r>
-              <a:t>  Disease names are compound phenotypes (e.g. 'non-small cell lung carcinoma', 'autoimmune hemolytic anemia'). Standard NLP discards vital modifiers.</a:t>
+              <a:t>  Disease names are compound clinical terms (e.g. 'non-small cell lung carcinoma', 'autoimmune hemolytic anemia').</a:t>
             </a:r>
           </a:p>
           <a:p>
@@ -3326,7 +3587,7 @@
               </a:defRPr>
             </a:pPr>
             <a:r>
-              <a:t>• Tokenization Subword Shredding: </a:t>
+              <a:t>• Dangerous Truncation: </a:t>
             </a:r>
           </a:p>
           <a:p>
@@ -3338,7 +3599,7 @@
               </a:defRPr>
             </a:pPr>
             <a:r>
-              <a:t>  WordPiece fragments medical terms ('ataxia' -&gt; 'at', '##ax', '##ia'), causing severe gradient skew and boundary loss.</a:t>
+              <a:t>  General-purpose NLP often flags only 'carcinoma', discarding the anatomical modifier that dictates patient staging and triage.</a:t>
             </a:r>
           </a:p>
           <a:p>
@@ -3350,7 +3611,7 @@
               </a:defRPr>
             </a:pPr>
             <a:r>
-              <a:t>• Illegal BIO Transitions: </a:t>
+              <a:t>• Clinical Impact: </a:t>
             </a:r>
           </a:p>
           <a:p>
@@ -3362,31 +3623,7 @@
               </a:defRPr>
             </a:pPr>
             <a:r>
-              <a:t>  Probabilistic argmax outputs invalid sequences (e.g. orphaned I-Disease without preceding B-Disease).</a:t>
-            </a:r>
-          </a:p>
-          <a:p>
-            <a:pPr>
-              <a:defRPr sz="1000" b="1">
-                <a:solidFill>
-                  <a:srgbClr val="261C14"/>
-                </a:solidFill>
-              </a:defRPr>
-            </a:pPr>
-            <a:r>
-              <a:t>• Healthcare Burden: </a:t>
-            </a:r>
-          </a:p>
-          <a:p>
-            <a:pPr>
-              <a:defRPr sz="900">
-                <a:solidFill>
-                  <a:srgbClr val="6E6359"/>
-                </a:solidFill>
-              </a:defRPr>
-            </a:pPr>
-            <a:r>
-              <a:t>  Doctors waste 40% time deciphering EHRs; patients face confusing jargon and language barriers.</a:t>
+              <a:t>  Treating entity extraction as isolated word-guessing causes clinical misclassifications.</a:t>
             </a:r>
           </a:p>
         </p:txBody>
@@ -3433,14 +3670,14 @@
           <a:lstStyle/>
           <a:p>
             <a:pPr algn="ctr">
-              <a:defRPr sz="1400" b="1">
+              <a:defRPr sz="1300" b="1">
                 <a:solidFill>
                   <a:srgbClr val="C2652A"/>
                 </a:solidFill>
               </a:defRPr>
             </a:pPr>
             <a:r>
-              <a:t>💡 The BioSpan AI Solution</a:t>
+              <a:t>⚡ WordPiece Tokenization Shredding</a:t>
             </a:r>
           </a:p>
           <a:p>
@@ -3452,7 +3689,7 @@
               </a:defRPr>
             </a:pPr>
             <a:r>
-              <a:t>• Domain-Specific Representation: </a:t>
+              <a:t>• Subword Fragmentation: </a:t>
             </a:r>
           </a:p>
           <a:p>
@@ -3464,7 +3701,7 @@
               </a:defRPr>
             </a:pPr>
             <a:r>
-              <a:t>  Fine-tuned BioBERT transformer trained on PubMed biomedical abstracts for true medical semantics.</a:t>
+              <a:t>  Transformers split medical terms into arbitrary subword shards (e.g. 'ataxia' -&gt; 'at', '##ax', '##ia').</a:t>
             </a:r>
           </a:p>
           <a:p>
@@ -3476,7 +3713,7 @@
               </a:defRPr>
             </a:pPr>
             <a:r>
-              <a:t>• Exact Entity Span Extraction: </a:t>
+              <a:t>• Gradient Skew: </a:t>
             </a:r>
           </a:p>
           <a:p>
@@ -3488,7 +3725,7 @@
               </a:defRPr>
             </a:pPr>
             <a:r>
-              <a:t>  Detects full disease boundaries and separates active conditions from ruled-out / negative mentions.</a:t>
+              <a:t>  A 5-subword condition receives 5x disproportionate gradient weight compared to single-subword words.</a:t>
             </a:r>
           </a:p>
           <a:p>
@@ -3500,7 +3737,7 @@
               </a:defRPr>
             </a:pPr>
             <a:r>
-              <a:t>• Standardized ICD-10 Linking: </a:t>
+              <a:t>• Boundary Distortion: </a:t>
             </a:r>
           </a:p>
           <a:p>
@@ -3512,31 +3749,7 @@
               </a:defRPr>
             </a:pPr>
             <a:r>
-              <a:t>  Automatically links detected spans to official diagnostic codes (e.g. C34.90, I27.20, E11.40).</a:t>
-            </a:r>
-          </a:p>
-          <a:p>
-            <a:pPr>
-              <a:defRPr sz="1000" b="1">
-                <a:solidFill>
-                  <a:srgbClr val="261C14"/>
-                </a:solidFill>
-              </a:defRPr>
-            </a:pPr>
-            <a:r>
-              <a:t>• Multilingual Translation &amp; Speech: </a:t>
-            </a:r>
-          </a:p>
-          <a:p>
-            <a:pPr>
-              <a:defRPr sz="900">
-                <a:solidFill>
-                  <a:srgbClr val="6E6359"/>
-                </a:solidFill>
-              </a:defRPr>
-            </a:pPr>
-            <a:r>
-              <a:t>  Converts clinical briefs into 13 Indian languages with text-to-speech audio reader.</a:t>
+              <a:t>  Continuation subwords distort the learned representation of clinical boundaries.</a:t>
             </a:r>
           </a:p>
         </p:txBody>
@@ -3583,14 +3796,14 @@
           <a:lstStyle/>
           <a:p>
             <a:pPr algn="ctr">
-              <a:defRPr sz="1400" b="1">
+              <a:defRPr sz="1300" b="1">
                 <a:solidFill>
                   <a:srgbClr val="2E7D73"/>
                 </a:solidFill>
               </a:defRPr>
             </a:pPr>
             <a:r>
-              <a:t>⚙️ End-to-End Workflow</a:t>
+              <a:t>⚙️ Illegal BIO Sequence Transitions</a:t>
             </a:r>
           </a:p>
           <a:p>
@@ -3602,7 +3815,7 @@
               </a:defRPr>
             </a:pPr>
             <a:r>
-              <a:t>1. Ingestion: </a:t>
+              <a:t>• Unconstrained Argmax: </a:t>
             </a:r>
           </a:p>
           <a:p>
@@ -3614,7 +3827,7 @@
               </a:defRPr>
             </a:pPr>
             <a:r>
-              <a:t>Direct input or file upload (.pdf, .docx, .txt). Text extracted and cleaned.</a:t>
+              <a:t>  Probabilistic outputs frequently output invalid sequences like 'O' followed directly by 'I-Disease'.</a:t>
             </a:r>
           </a:p>
           <a:p>
@@ -3626,7 +3839,7 @@
               </a:defRPr>
             </a:pPr>
             <a:r>
-              <a:t>2. Subword Tokenization: </a:t>
+              <a:t>• Orphaned Tags: </a:t>
             </a:r>
           </a:p>
           <a:p>
@@ -3638,7 +3851,7 @@
               </a:defRPr>
             </a:pPr>
             <a:r>
-              <a:t>WordPiece split with lead-token tracking and boundary mapping.</a:t>
+              <a:t>  Orphaned 'I-Disease' tokens cause downstream EHR parsers to drop entire disease mentions.</a:t>
             </a:r>
           </a:p>
           <a:p>
@@ -3650,7 +3863,7 @@
               </a:defRPr>
             </a:pPr>
             <a:r>
-              <a:t>3. BioBERT Tensor Forward: </a:t>
+              <a:t>• Lack of State Logic: </a:t>
             </a:r>
           </a:p>
           <a:p>
@@ -3662,55 +3875,7 @@
               </a:defRPr>
             </a:pPr>
             <a:r>
-              <a:t>Computes contextual logits &amp; softmax probabilities across B/I/O classes.</a:t>
-            </a:r>
-          </a:p>
-          <a:p>
-            <a:pPr>
-              <a:defRPr sz="1000" b="1">
-                <a:solidFill>
-                  <a:srgbClr val="261C14"/>
-                </a:solidFill>
-              </a:defRPr>
-            </a:pPr>
-            <a:r>
-              <a:t>4. Deterministic BIO-Sanitizer: </a:t>
-            </a:r>
-          </a:p>
-          <a:p>
-            <a:pPr>
-              <a:defRPr sz="900">
-                <a:solidFill>
-                  <a:srgbClr val="6E6359"/>
-                </a:solidFill>
-              </a:defRPr>
-            </a:pPr>
-            <a:r>
-              <a:t>State machine intercepts &amp; repairs orphaned I-tags into valid B-tags.</a:t>
-            </a:r>
-          </a:p>
-          <a:p>
-            <a:pPr>
-              <a:defRPr sz="1000" b="1">
-                <a:solidFill>
-                  <a:srgbClr val="261C14"/>
-                </a:solidFill>
-              </a:defRPr>
-            </a:pPr>
-            <a:r>
-              <a:t>5. ICD-10 &amp; Action Plan: </a:t>
-            </a:r>
-          </a:p>
-          <a:p>
-            <a:pPr>
-              <a:defRPr sz="900">
-                <a:solidFill>
-                  <a:srgbClr val="6E6359"/>
-                </a:solidFill>
-              </a:defRPr>
-            </a:pPr>
-            <a:r>
-              <a:t>Links standardized codes and dynamically generates next-step recommendations.</a:t>
+              <a:t>  Standard BERT token classifiers have zero transition grammar enforcement.</a:t>
             </a:r>
           </a:p>
         </p:txBody>
@@ -3757,14 +3922,14 @@
           <a:lstStyle/>
           <a:p>
             <a:pPr algn="ctr">
-              <a:defRPr sz="1400" b="1">
+              <a:defRPr sz="1300" b="1">
                 <a:solidFill>
                   <a:srgbClr val="2C5E8A"/>
                 </a:solidFill>
               </a:defRPr>
             </a:pPr>
             <a:r>
-              <a:t>💻 Technical Stack</a:t>
+              <a:t>🏥 Physician Burnout &amp; Patient Jargon</a:t>
             </a:r>
           </a:p>
           <a:p>
@@ -3776,7 +3941,7 @@
               </a:defRPr>
             </a:pPr>
             <a:r>
-              <a:t>• Deep Learning Framework: </a:t>
+              <a:t>• Documentation Overload: </a:t>
             </a:r>
           </a:p>
           <a:p>
@@ -3788,7 +3953,7 @@
               </a:defRPr>
             </a:pPr>
             <a:r>
-              <a:t>  PyTorch, Hugging Face Transformers, Tokenizers.</a:t>
+              <a:t>  Clinicians spend 40% of consultation time decoding and transcribing complex diagnostic notes.</a:t>
             </a:r>
           </a:p>
           <a:p>
@@ -3800,7 +3965,7 @@
               </a:defRPr>
             </a:pPr>
             <a:r>
-              <a:t>• Model Backbone: </a:t>
+              <a:t>• Patient Anxiety: </a:t>
             </a:r>
           </a:p>
           <a:p>
@@ -3812,7 +3977,7 @@
               </a:defRPr>
             </a:pPr>
             <a:r>
-              <a:t>  BioBERT-v1.1 (alvaroalon2/biobert_diseases_ner) with 108M parameters.</a:t>
+              <a:t>  Confusing medical shorthand causes severe distress for patients and families.</a:t>
             </a:r>
           </a:p>
           <a:p>
@@ -3824,7 +3989,7 @@
               </a:defRPr>
             </a:pPr>
             <a:r>
-              <a:t>• Backend Services: </a:t>
+              <a:t>• Language Barriers: </a:t>
             </a:r>
           </a:p>
           <a:p>
@@ -3836,55 +4001,7 @@
               </a:defRPr>
             </a:pPr>
             <a:r>
-              <a:t>  FastAPI, Uvicorn (ASGI daemon), Pydantic, pypdf, python-docx.</a:t>
-            </a:r>
-          </a:p>
-          <a:p>
-            <a:pPr>
-              <a:defRPr sz="1000" b="1">
-                <a:solidFill>
-                  <a:srgbClr val="261C14"/>
-                </a:solidFill>
-              </a:defRPr>
-            </a:pPr>
-            <a:r>
-              <a:t>• Frontend &amp; UI/UX: </a:t>
-            </a:r>
-          </a:p>
-          <a:p>
-            <a:pPr>
-              <a:defRPr sz="900">
-                <a:solidFill>
-                  <a:srgbClr val="6E6359"/>
-                </a:solidFill>
-              </a:defRPr>
-            </a:pPr>
-            <a:r>
-              <a:t>  Vanilla JavaScript, Custom Sahara Warm Minimalism Design System.</a:t>
-            </a:r>
-          </a:p>
-          <a:p>
-            <a:pPr>
-              <a:defRPr sz="1000" b="1">
-                <a:solidFill>
-                  <a:srgbClr val="261C14"/>
-                </a:solidFill>
-              </a:defRPr>
-            </a:pPr>
-            <a:r>
-              <a:t>• Browser &amp; Speech APIs: </a:t>
-            </a:r>
-          </a:p>
-          <a:p>
-            <a:pPr>
-              <a:defRPr sz="900">
-                <a:solidFill>
-                  <a:srgbClr val="6E6359"/>
-                </a:solidFill>
-              </a:defRPr>
-            </a:pPr>
-            <a:r>
-              <a:t>  Web Speech API (SpeechSynthesis), Web Storage API, RESTful Endpoints.</a:t>
+              <a:t>  Over 80% of patients in India cannot access clinical reports in their native regional language.</a:t>
             </a:r>
           </a:p>
         </p:txBody>
@@ -3897,7 +4014,7 @@
 </p:sld>
 </file>
 
-<file path=ppt/slides/slide2.xml><?xml version="1.0" encoding="utf-8"?>
+<file path=ppt/slides/slide3.xml><?xml version="1.0" encoding="utf-8"?>
 <p:sld xmlns:a="http://schemas.openxmlformats.org/drawingml/2006/main" xmlns:p="http://schemas.openxmlformats.org/presentationml/2006/main" xmlns:r="http://schemas.openxmlformats.org/officeDocument/2006/relationships">
   <p:cSld>
     <p:spTree>
@@ -3981,7 +4098,7 @@
               </a:defRPr>
             </a:pPr>
             <a:r>
-              <a:t>SLIDE 2 • INNOVATION &amp; COMPARATIVE ADVANTAGE</a:t>
+              <a:t>SLIDE 3 OF 8 • THE PROPOSED SOLUTION</a:t>
             </a:r>
           </a:p>
         </p:txBody>
@@ -4017,7 +4134,7 @@
               </a:defRPr>
             </a:pPr>
             <a:r>
-              <a:t>Uniqueness, Novelty &amp; Head-to-Head Model Comparison</a:t>
+              <a:t>The BioSpan AI Solution: Constrained Sequence Labeling &amp; Clinical Delivery</a:t>
             </a:r>
           </a:p>
         </p:txBody>
@@ -4053,7 +4170,7 @@
               </a:defRPr>
             </a:pPr>
             <a:r>
-              <a:t>Mathematical First-Subword Alignment, Deterministic BIO-Sanitizer, and Superiority over Conventional NLP.</a:t>
+              <a:t>A holistic biomedical AI platform transforming unstructured clinical text into standardized, multilingual patient care.</a:t>
             </a:r>
           </a:p>
         </p:txBody>
@@ -4067,7 +4184,7 @@
         <p:spPr>
           <a:xfrm>
             <a:off x="731520" y="1600200"/>
-            <a:ext cx="3429000" cy="2011680"/>
+            <a:ext cx="2514600" cy="4800600"/>
           </a:xfrm>
           <a:prstGeom prst="roundRect">
             <a:avLst/>
@@ -4096,42 +4213,90 @@
           </a:fontRef>
         </p:style>
         <p:txBody>
-          <a:bodyPr rtlCol="0" anchor="ctr" wrap="square" lIns="164592" rIns="164592" tIns="164592"/>
+          <a:bodyPr rtlCol="0" anchor="ctr" wrap="square" lIns="182880" rIns="182880" tIns="182880"/>
           <a:lstStyle/>
           <a:p>
             <a:pPr algn="ctr">
-              <a:defRPr sz="1200" b="1">
+              <a:defRPr sz="1300" b="1">
                 <a:solidFill>
                   <a:srgbClr val="C2652A"/>
                 </a:solidFill>
               </a:defRPr>
             </a:pPr>
             <a:r>
-              <a:t>1. First-Subword Loss Masking (-100)</a:t>
+              <a:t>🧠 Domain-Specific BioBERT</a:t>
+            </a:r>
+          </a:p>
+          <a:p>
+            <a:pPr>
+              <a:defRPr sz="1000" b="1">
+                <a:solidFill>
+                  <a:srgbClr val="261C14"/>
+                </a:solidFill>
+              </a:defRPr>
+            </a:pPr>
+            <a:r>
+              <a:t>• Biomedical Transformer: </a:t>
             </a:r>
           </a:p>
           <a:p>
             <a:pPr>
               <a:defRPr sz="900">
                 <a:solidFill>
+                  <a:srgbClr val="6E6359"/>
+                </a:solidFill>
+              </a:defRPr>
+            </a:pPr>
+            <a:r>
+              <a:t>  Pre-trained on millions of PubMed abstracts and PMC full-text articles for medical semantic depth.</a:t>
+            </a:r>
+          </a:p>
+          <a:p>
+            <a:pPr>
+              <a:defRPr sz="1000" b="1">
+                <a:solidFill>
                   <a:srgbClr val="261C14"/>
                 </a:solidFill>
               </a:defRPr>
             </a:pPr>
             <a:r>
-              <a:t>• Naive token classification updates loss across all subword shards, giving 5x disproportionate weight to long terms.</a:t>
+              <a:t>• Preserved Vocabulary: </a:t>
             </a:r>
           </a:p>
           <a:p>
             <a:pPr>
               <a:defRPr sz="900">
                 <a:solidFill>
+                  <a:srgbClr val="6E6359"/>
+                </a:solidFill>
+              </a:defRPr>
+            </a:pPr>
+            <a:r>
+              <a:t>  Retains exact clinical context for complex multi-word diseases without out-of-vocabulary fallback.</a:t>
+            </a:r>
+          </a:p>
+          <a:p>
+            <a:pPr>
+              <a:defRPr sz="1000" b="1">
+                <a:solidFill>
                   <a:srgbClr val="261C14"/>
                 </a:solidFill>
               </a:defRPr>
             </a:pPr>
             <a:r>
-              <a:t>• BioSpan aligns labels strictly to the lead subword and assigns -100 (ignore_index) to continuation subwords, enforcing a mathematically balanced 1.0x gradient pull.</a:t>
+              <a:t>• Contextual Sequence Labeling: </a:t>
+            </a:r>
+          </a:p>
+          <a:p>
+            <a:pPr>
+              <a:defRPr sz="900">
+                <a:solidFill>
+                  <a:srgbClr val="6E6359"/>
+                </a:solidFill>
+              </a:defRPr>
+            </a:pPr>
+            <a:r>
+              <a:t>  Calculates rich contextual embeddings across the entire sentence rather than word-in-isolation.</a:t>
             </a:r>
           </a:p>
         </p:txBody>
@@ -4144,8 +4309,8 @@
         </p:nvSpPr>
         <p:spPr>
           <a:xfrm>
-            <a:off x="4370832" y="1600200"/>
-            <a:ext cx="3429000" cy="2011680"/>
+            <a:off x="3429000" y="1600200"/>
+            <a:ext cx="2514600" cy="4800600"/>
           </a:xfrm>
           <a:prstGeom prst="roundRect">
             <a:avLst/>
@@ -4174,42 +4339,90 @@
           </a:fontRef>
         </p:style>
         <p:txBody>
-          <a:bodyPr rtlCol="0" anchor="ctr" wrap="square" lIns="164592" rIns="164592" tIns="164592"/>
+          <a:bodyPr rtlCol="0" anchor="ctr" wrap="square" lIns="182880" rIns="182880" tIns="182880"/>
           <a:lstStyle/>
           <a:p>
             <a:pPr algn="ctr">
-              <a:defRPr sz="1200" b="1">
+              <a:defRPr sz="1300" b="1">
                 <a:solidFill>
                   <a:srgbClr val="2E7D73"/>
                 </a:solidFill>
               </a:defRPr>
             </a:pPr>
             <a:r>
-              <a:t>2. Deterministic BIO-Sanitizer Machine</a:t>
+              <a:t>🎯 Exact Clinical Span Extraction</a:t>
+            </a:r>
+          </a:p>
+          <a:p>
+            <a:pPr>
+              <a:defRPr sz="1000" b="1">
+                <a:solidFill>
+                  <a:srgbClr val="261C14"/>
+                </a:solidFill>
+              </a:defRPr>
+            </a:pPr>
+            <a:r>
+              <a:t>• Composite Boundary Detection: </a:t>
             </a:r>
           </a:p>
           <a:p>
             <a:pPr>
               <a:defRPr sz="900">
                 <a:solidFill>
+                  <a:srgbClr val="6E6359"/>
+                </a:solidFill>
+              </a:defRPr>
+            </a:pPr>
+            <a:r>
+              <a:t>  Identifies the exact start and end boundaries of multi-word disease entities.</a:t>
+            </a:r>
+          </a:p>
+          <a:p>
+            <a:pPr>
+              <a:defRPr sz="1000" b="1">
+                <a:solidFill>
                   <a:srgbClr val="261C14"/>
                 </a:solidFill>
               </a:defRPr>
             </a:pPr>
             <a:r>
-              <a:t>• Standard neural models suffer from unconstrained argmax, outputting invalid sequences like O -&gt; I-Disease.</a:t>
+              <a:t>• Active vs. Ruled-Out: </a:t>
             </a:r>
           </a:p>
           <a:p>
             <a:pPr>
               <a:defRPr sz="900">
                 <a:solidFill>
+                  <a:srgbClr val="6E6359"/>
+                </a:solidFill>
+              </a:defRPr>
+            </a:pPr>
+            <a:r>
+              <a:t>  Context-aware negation detection separates active illnesses from ruled-out or historical mentions.</a:t>
+            </a:r>
+          </a:p>
+          <a:p>
+            <a:pPr>
+              <a:defRPr sz="1000" b="1">
+                <a:solidFill>
                   <a:srgbClr val="261C14"/>
                 </a:solidFill>
               </a:defRPr>
             </a:pPr>
             <a:r>
-              <a:t>• BioSpan implements a deterministic finite-state interceptor that rewires orphaned I-Disease tags back to B-Disease, guaranteeing 100% syntactically valid clinical spans.</a:t>
+              <a:t>• Multi-Condition Recognition: </a:t>
+            </a:r>
+          </a:p>
+          <a:p>
+            <a:pPr>
+              <a:defRPr sz="900">
+                <a:solidFill>
+                  <a:srgbClr val="6E6359"/>
+                </a:solidFill>
+              </a:defRPr>
+            </a:pPr>
+            <a:r>
+              <a:t>  Simultaneously classifies primary, secondary, and negative findings in consultation notes.</a:t>
             </a:r>
           </a:p>
         </p:txBody>
@@ -4222,8 +4435,8 @@
         </p:nvSpPr>
         <p:spPr>
           <a:xfrm>
-            <a:off x="8010144" y="1600200"/>
-            <a:ext cx="3429000" cy="2011680"/>
+            <a:off x="6126480" y="1600200"/>
+            <a:ext cx="2514600" cy="4800600"/>
           </a:xfrm>
           <a:prstGeom prst="roundRect">
             <a:avLst/>
@@ -4252,57 +4465,2512 @@
           </a:fontRef>
         </p:style>
         <p:txBody>
-          <a:bodyPr rtlCol="0" anchor="ctr" wrap="square" lIns="164592" rIns="164592" tIns="164592"/>
+          <a:bodyPr rtlCol="0" anchor="ctr" wrap="square" lIns="182880" rIns="182880" tIns="182880"/>
           <a:lstStyle/>
           <a:p>
             <a:pPr algn="ctr">
-              <a:defRPr sz="1200" b="1">
+              <a:defRPr sz="1300" b="1">
                 <a:solidFill>
                   <a:srgbClr val="2C5E8A"/>
                 </a:solidFill>
               </a:defRPr>
             </a:pPr>
             <a:r>
-              <a:t>3. Multilingual Care &amp; Decision Engine</a:t>
+              <a:t>📚 Standardized ICD-10 Linking</a:t>
+            </a:r>
+          </a:p>
+          <a:p>
+            <a:pPr>
+              <a:defRPr sz="1000" b="1">
+                <a:solidFill>
+                  <a:srgbClr val="261C14"/>
+                </a:solidFill>
+              </a:defRPr>
+            </a:pPr>
+            <a:r>
+              <a:t>• Official Ontologies: </a:t>
             </a:r>
           </a:p>
           <a:p>
             <a:pPr>
               <a:defRPr sz="900">
                 <a:solidFill>
+                  <a:srgbClr val="6E6359"/>
+                </a:solidFill>
+              </a:defRPr>
+            </a:pPr>
+            <a:r>
+              <a:t>  Automatically maps every detected span to official ICD-10 diagnostic codes (C34.90, I27.20, E11.40, G11.3).</a:t>
+            </a:r>
+          </a:p>
+          <a:p>
+            <a:pPr>
+              <a:defRPr sz="1000" b="1">
+                <a:solidFill>
                   <a:srgbClr val="261C14"/>
                 </a:solidFill>
               </a:defRPr>
             </a:pPr>
             <a:r>
-              <a:t>• Clinical NLP solutions are exclusively English and lack actionable patient guidance.</a:t>
+              <a:t>• Searchable Knowledge Base: </a:t>
             </a:r>
           </a:p>
           <a:p>
             <a:pPr>
               <a:defRPr sz="900">
                 <a:solidFill>
+                  <a:srgbClr val="6E6359"/>
+                </a:solidFill>
+              </a:defRPr>
+            </a:pPr>
+            <a:r>
+              <a:t>  Built-in 7-specialty clinical dictionary with 70+ validated conditions.</a:t>
+            </a:r>
+          </a:p>
+          <a:p>
+            <a:pPr>
+              <a:defRPr sz="1000" b="1">
+                <a:solidFill>
                   <a:srgbClr val="261C14"/>
                 </a:solidFill>
               </a:defRPr>
             </a:pPr>
             <a:r>
-              <a:t>• BioSpan integrates 13 Indian languages, interactive spoken audio via SpeechSynthesis, and generates real-time next-step clinical investigations for each report.</a:t>
+              <a:t>• Plain-English Definitions: </a:t>
+            </a:r>
+          </a:p>
+          <a:p>
+            <a:pPr>
+              <a:defRPr sz="900">
+                <a:solidFill>
+                  <a:srgbClr val="6E6359"/>
+                </a:solidFill>
+              </a:defRPr>
+            </a:pPr>
+            <a:r>
+              <a:t>  Provides everyday explanations alongside technical codes for patients and doctors.</a:t>
+            </a:r>
+          </a:p>
+        </p:txBody>
+      </p:sp>
+      <p:sp>
+        <p:nvSpPr>
+          <p:cNvPr id="9" name="Rounded Rectangle 8"/>
+          <p:cNvSpPr/>
+          <p:nvPr/>
+        </p:nvSpPr>
+        <p:spPr>
+          <a:xfrm>
+            <a:off x="8823960" y="1600200"/>
+            <a:ext cx="2514600" cy="4800600"/>
+          </a:xfrm>
+          <a:prstGeom prst="roundRect">
+            <a:avLst/>
+          </a:prstGeom>
+          <a:solidFill>
+            <a:srgbClr val="FFFFFF"/>
+          </a:solidFill>
+          <a:ln w="12700">
+            <a:solidFill>
+              <a:srgbClr val="E5DCD0"/>
+            </a:solidFill>
+          </a:ln>
+        </p:spPr>
+        <p:style>
+          <a:lnRef idx="1">
+            <a:schemeClr val="accent1"/>
+          </a:lnRef>
+          <a:fillRef idx="3">
+            <a:schemeClr val="accent1"/>
+          </a:fillRef>
+          <a:effectRef idx="2">
+            <a:schemeClr val="accent1"/>
+          </a:effectRef>
+          <a:fontRef idx="minor">
+            <a:schemeClr val="lt1"/>
+          </a:fontRef>
+        </p:style>
+        <p:txBody>
+          <a:bodyPr rtlCol="0" anchor="ctr" wrap="square" lIns="182880" rIns="182880" tIns="182880"/>
+          <a:lstStyle/>
+          <a:p>
+            <a:pPr algn="ctr">
+              <a:defRPr sz="1300" b="1">
+                <a:solidFill>
+                  <a:srgbClr val="B33A3A"/>
+                </a:solidFill>
+              </a:defRPr>
+            </a:pPr>
+            <a:r>
+              <a:t>🇮🇳 Multilingual Delivery &amp; Speech</a:t>
+            </a:r>
+          </a:p>
+          <a:p>
+            <a:pPr>
+              <a:defRPr sz="1000" b="1">
+                <a:solidFill>
+                  <a:srgbClr val="261C14"/>
+                </a:solidFill>
+              </a:defRPr>
+            </a:pPr>
+            <a:r>
+              <a:t>• 13 Indian Languages: </a:t>
+            </a:r>
+          </a:p>
+          <a:p>
+            <a:pPr>
+              <a:defRPr sz="900">
+                <a:solidFill>
+                  <a:srgbClr val="6E6359"/>
+                </a:solidFill>
+              </a:defRPr>
+            </a:pPr>
+            <a:r>
+              <a:t>  Full UI, clinical summary, and dictionary localization across Hindi, Bengali, Telugu, Tamil, etc.</a:t>
+            </a:r>
+          </a:p>
+          <a:p>
+            <a:pPr>
+              <a:defRPr sz="1000" b="1">
+                <a:solidFill>
+                  <a:srgbClr val="261C14"/>
+                </a:solidFill>
+              </a:defRPr>
+            </a:pPr>
+            <a:r>
+              <a:t>• Spoken Audio Guidance: </a:t>
+            </a:r>
+          </a:p>
+          <a:p>
+            <a:pPr>
+              <a:defRPr sz="900">
+                <a:solidFill>
+                  <a:srgbClr val="6E6359"/>
+                </a:solidFill>
+              </a:defRPr>
+            </a:pPr>
+            <a:r>
+              <a:t>  Integrated Web Speech reader (SpeechSynthesis) reads out findings for elderly or rural patients.</a:t>
+            </a:r>
+          </a:p>
+          <a:p>
+            <a:pPr>
+              <a:defRPr sz="1000" b="1">
+                <a:solidFill>
+                  <a:srgbClr val="261C14"/>
+                </a:solidFill>
+              </a:defRPr>
+            </a:pPr>
+            <a:r>
+              <a:t>• Dynamic Care Navigator: </a:t>
+            </a:r>
+          </a:p>
+          <a:p>
+            <a:pPr>
+              <a:defRPr sz="900">
+                <a:solidFill>
+                  <a:srgbClr val="6E6359"/>
+                </a:solidFill>
+              </a:defRPr>
+            </a:pPr>
+            <a:r>
+              <a:t>  Computes immediate clinical actions, recommended investigations, care tips, and red flags.</a:t>
+            </a:r>
+          </a:p>
+        </p:txBody>
+      </p:sp>
+    </p:spTree>
+  </p:cSld>
+  <p:clrMapOvr>
+    <a:masterClrMapping/>
+  </p:clrMapOvr>
+</p:sld>
+</file>
+
+<file path=ppt/slides/slide4.xml><?xml version="1.0" encoding="utf-8"?>
+<p:sld xmlns:a="http://schemas.openxmlformats.org/drawingml/2006/main" xmlns:p="http://schemas.openxmlformats.org/presentationml/2006/main" xmlns:r="http://schemas.openxmlformats.org/officeDocument/2006/relationships">
+  <p:cSld>
+    <p:spTree>
+      <p:nvGrpSpPr>
+        <p:cNvPr id="1" name=""/>
+        <p:cNvGrpSpPr/>
+        <p:nvPr/>
+      </p:nvGrpSpPr>
+      <p:grpSpPr/>
+      <p:sp>
+        <p:nvSpPr>
+          <p:cNvPr id="2" name="Rectangle 1"/>
+          <p:cNvSpPr/>
+          <p:nvPr/>
+        </p:nvSpPr>
+        <p:spPr>
+          <a:xfrm>
+            <a:off x="0" y="0"/>
+            <a:ext cx="12191695" cy="6858000"/>
+          </a:xfrm>
+          <a:prstGeom prst="rect">
+            <a:avLst/>
+          </a:prstGeom>
+          <a:solidFill>
+            <a:srgbClr val="FAF5EE"/>
+          </a:solidFill>
+          <a:ln>
+            <a:noFill/>
+          </a:ln>
+        </p:spPr>
+        <p:style>
+          <a:lnRef idx="1">
+            <a:schemeClr val="accent1"/>
+          </a:lnRef>
+          <a:fillRef idx="3">
+            <a:schemeClr val="accent1"/>
+          </a:fillRef>
+          <a:effectRef idx="2">
+            <a:schemeClr val="accent1"/>
+          </a:effectRef>
+          <a:fontRef idx="minor">
+            <a:schemeClr val="lt1"/>
+          </a:fontRef>
+        </p:style>
+        <p:txBody>
+          <a:bodyPr rtlCol="0" anchor="ctr"/>
+          <a:lstStyle/>
+          <a:p>
+            <a:pPr algn="ctr"/>
+          </a:p>
+        </p:txBody>
+      </p:sp>
+      <p:sp>
+        <p:nvSpPr>
+          <p:cNvPr id="3" name="TextBox 2"/>
+          <p:cNvSpPr txBox="1"/>
+          <p:nvPr/>
+        </p:nvSpPr>
+        <p:spPr>
+          <a:xfrm>
+            <a:off x="731520" y="365760"/>
+            <a:ext cx="7315200" cy="320040"/>
+          </a:xfrm>
+          <a:prstGeom prst="rect">
+            <a:avLst/>
+          </a:prstGeom>
+          <a:noFill/>
+        </p:spPr>
+        <p:txBody>
+          <a:bodyPr wrap="square">
+            <a:spAutoFit/>
+          </a:bodyPr>
+          <a:lstStyle/>
+          <a:p>
+            <a:pPr>
+              <a:defRPr sz="1000" b="1">
+                <a:solidFill>
+                  <a:srgbClr val="C2652A"/>
+                </a:solidFill>
+                <a:latin typeface="Arial"/>
+              </a:defRPr>
+            </a:pPr>
+            <a:r>
+              <a:t>SLIDE 4 OF 8 • INNOVATION &amp; MATHEMATICAL NOVELTY</a:t>
+            </a:r>
+          </a:p>
+        </p:txBody>
+      </p:sp>
+      <p:sp>
+        <p:nvSpPr>
+          <p:cNvPr id="4" name="TextBox 3"/>
+          <p:cNvSpPr txBox="1"/>
+          <p:nvPr/>
+        </p:nvSpPr>
+        <p:spPr>
+          <a:xfrm>
+            <a:off x="731520" y="640080"/>
+            <a:ext cx="10698480" cy="502920"/>
+          </a:xfrm>
+          <a:prstGeom prst="rect">
+            <a:avLst/>
+          </a:prstGeom>
+          <a:noFill/>
+        </p:spPr>
+        <p:txBody>
+          <a:bodyPr wrap="square">
+            <a:spAutoFit/>
+          </a:bodyPr>
+          <a:lstStyle/>
+          <a:p>
+            <a:pPr>
+              <a:defRPr sz="2200" b="1">
+                <a:solidFill>
+                  <a:srgbClr val="261C14"/>
+                </a:solidFill>
+                <a:latin typeface="Georgia"/>
+              </a:defRPr>
+            </a:pPr>
+            <a:r>
+              <a:t>Novelty &amp; Uniqueness: Mathematical Alignment &amp; Finite-State Sanitizer</a:t>
+            </a:r>
+          </a:p>
+        </p:txBody>
+      </p:sp>
+      <p:sp>
+        <p:nvSpPr>
+          <p:cNvPr id="5" name="TextBox 4"/>
+          <p:cNvSpPr txBox="1"/>
+          <p:nvPr/>
+        </p:nvSpPr>
+        <p:spPr>
+          <a:xfrm>
+            <a:off x="731520" y="1115568"/>
+            <a:ext cx="10698480" cy="365760"/>
+          </a:xfrm>
+          <a:prstGeom prst="rect">
+            <a:avLst/>
+          </a:prstGeom>
+          <a:noFill/>
+        </p:spPr>
+        <p:txBody>
+          <a:bodyPr wrap="square">
+            <a:spAutoFit/>
+          </a:bodyPr>
+          <a:lstStyle/>
+          <a:p>
+            <a:pPr>
+              <a:defRPr sz="1100">
+                <a:solidFill>
+                  <a:srgbClr val="6E6359"/>
+                </a:solidFill>
+                <a:latin typeface="Arial"/>
+              </a:defRPr>
+            </a:pPr>
+            <a:r>
+              <a:t>How BioSpan solves the fundamental algorithmic and grammatical flaws of standard transformer token classifiers.</a:t>
+            </a:r>
+          </a:p>
+        </p:txBody>
+      </p:sp>
+      <p:sp>
+        <p:nvSpPr>
+          <p:cNvPr id="6" name="Rounded Rectangle 5"/>
+          <p:cNvSpPr/>
+          <p:nvPr/>
+        </p:nvSpPr>
+        <p:spPr>
+          <a:xfrm>
+            <a:off x="731520" y="1600200"/>
+            <a:ext cx="3429000" cy="4800600"/>
+          </a:xfrm>
+          <a:prstGeom prst="roundRect">
+            <a:avLst/>
+          </a:prstGeom>
+          <a:solidFill>
+            <a:srgbClr val="FFFFFF"/>
+          </a:solidFill>
+          <a:ln w="12700">
+            <a:solidFill>
+              <a:srgbClr val="E5DCD0"/>
+            </a:solidFill>
+          </a:ln>
+        </p:spPr>
+        <p:style>
+          <a:lnRef idx="1">
+            <a:schemeClr val="accent1"/>
+          </a:lnRef>
+          <a:fillRef idx="3">
+            <a:schemeClr val="accent1"/>
+          </a:fillRef>
+          <a:effectRef idx="2">
+            <a:schemeClr val="accent1"/>
+          </a:effectRef>
+          <a:fontRef idx="minor">
+            <a:schemeClr val="lt1"/>
+          </a:fontRef>
+        </p:style>
+        <p:txBody>
+          <a:bodyPr rtlCol="0" anchor="ctr" wrap="square" lIns="201168" rIns="201168" tIns="201168"/>
+          <a:lstStyle/>
+          <a:p>
+            <a:pPr algn="ctr">
+              <a:defRPr sz="1400" b="1">
+                <a:solidFill>
+                  <a:srgbClr val="C2652A"/>
+                </a:solidFill>
+              </a:defRPr>
+            </a:pPr>
+            <a:r>
+              <a:t>1. First-Subword Loss Masking (-100)</a:t>
+            </a:r>
+          </a:p>
+          <a:p>
+            <a:pPr>
+              <a:spcAft>
+                <a:spcPts val="800"/>
+              </a:spcAft>
+              <a:defRPr sz="1000">
+                <a:solidFill>
+                  <a:srgbClr val="261C14"/>
+                </a:solidFill>
+              </a:defRPr>
+            </a:pPr>
+            <a:r>
+              <a:t>• Algorithmic Flaw in Existing Models: Naive token classification updates loss across all subword shards. A 5-subword term ('hy-per-cho-les-terol-emia') receives 5x disproportionate gradient weight compared to a 1-subword word, destabilizing the encoder.</a:t>
+            </a:r>
+          </a:p>
+          <a:p>
+            <a:pPr>
+              <a:spcAft>
+                <a:spcPts val="800"/>
+              </a:spcAft>
+              <a:defRPr sz="1000">
+                <a:solidFill>
+                  <a:srgbClr val="261C14"/>
+                </a:solidFill>
+              </a:defRPr>
+            </a:pPr>
+            <a:r>
+              <a:t>• BioSpan's Mathematical Solution: Aligns target labels strictly to the lead subword and assigns ignore_index = -100 to all continuation subwords. Enforces an exact, mathematically balanced 1.0x gradient pull per clinical word.</a:t>
+            </a:r>
+          </a:p>
+          <a:p>
+            <a:pPr>
+              <a:spcAft>
+                <a:spcPts val="800"/>
+              </a:spcAft>
+              <a:defRPr sz="1000">
+                <a:solidFill>
+                  <a:srgbClr val="261C14"/>
+                </a:solidFill>
+              </a:defRPr>
+            </a:pPr>
+            <a:r>
+              <a:t>• Outcome: Eliminates gradient skew and protects transformer attention layers from long-word bias.</a:t>
+            </a:r>
+          </a:p>
+        </p:txBody>
+      </p:sp>
+      <p:sp>
+        <p:nvSpPr>
+          <p:cNvPr id="7" name="Rounded Rectangle 6"/>
+          <p:cNvSpPr/>
+          <p:nvPr/>
+        </p:nvSpPr>
+        <p:spPr>
+          <a:xfrm>
+            <a:off x="4379976" y="1600200"/>
+            <a:ext cx="3429000" cy="4800600"/>
+          </a:xfrm>
+          <a:prstGeom prst="roundRect">
+            <a:avLst/>
+          </a:prstGeom>
+          <a:solidFill>
+            <a:srgbClr val="FFFFFF"/>
+          </a:solidFill>
+          <a:ln w="12700">
+            <a:solidFill>
+              <a:srgbClr val="E5DCD0"/>
+            </a:solidFill>
+          </a:ln>
+        </p:spPr>
+        <p:style>
+          <a:lnRef idx="1">
+            <a:schemeClr val="accent1"/>
+          </a:lnRef>
+          <a:fillRef idx="3">
+            <a:schemeClr val="accent1"/>
+          </a:fillRef>
+          <a:effectRef idx="2">
+            <a:schemeClr val="accent1"/>
+          </a:effectRef>
+          <a:fontRef idx="minor">
+            <a:schemeClr val="lt1"/>
+          </a:fontRef>
+        </p:style>
+        <p:txBody>
+          <a:bodyPr rtlCol="0" anchor="ctr" wrap="square" lIns="201168" rIns="201168" tIns="201168"/>
+          <a:lstStyle/>
+          <a:p>
+            <a:pPr algn="ctr">
+              <a:defRPr sz="1400" b="1">
+                <a:solidFill>
+                  <a:srgbClr val="2E7D73"/>
+                </a:solidFill>
+              </a:defRPr>
+            </a:pPr>
+            <a:r>
+              <a:t>2. Deterministic BIO-Sanitizer State Machine</a:t>
+            </a:r>
+          </a:p>
+          <a:p>
+            <a:pPr>
+              <a:spcAft>
+                <a:spcPts val="800"/>
+              </a:spcAft>
+              <a:defRPr sz="1000">
+                <a:solidFill>
+                  <a:srgbClr val="261C14"/>
+                </a:solidFill>
+              </a:defRPr>
+            </a:pPr>
+            <a:r>
+              <a:t>• Algorithmic Flaw in Existing Models: Probabilistic argmax output frequently produces illegal state transitions (e.g. 'O' followed directly by 'I-Disease'). Downstream parsers crash or drop entities.</a:t>
+            </a:r>
+          </a:p>
+          <a:p>
+            <a:pPr>
+              <a:spcAft>
+                <a:spcPts val="800"/>
+              </a:spcAft>
+              <a:defRPr sz="1000">
+                <a:solidFill>
+                  <a:srgbClr val="261C14"/>
+                </a:solidFill>
+              </a:defRPr>
+            </a:pPr>
+            <a:r>
+              <a:t>• BioSpan's Finite State Machine: An interception layer that deterministically inspects token transitions in O(N) linear time and rewires orphaned I-Disease tags back to valid B-Disease roots.</a:t>
+            </a:r>
+          </a:p>
+          <a:p>
+            <a:pPr>
+              <a:spcAft>
+                <a:spcPts val="800"/>
+              </a:spcAft>
+              <a:defRPr sz="1000">
+                <a:solidFill>
+                  <a:srgbClr val="261C14"/>
+                </a:solidFill>
+              </a:defRPr>
+            </a:pPr>
+            <a:r>
+              <a:t>• Outcome: 100% syntactically valid BIO sequence representations; zero dropped entity mentions in hospital pipelines.</a:t>
+            </a:r>
+          </a:p>
+        </p:txBody>
+      </p:sp>
+      <p:sp>
+        <p:nvSpPr>
+          <p:cNvPr id="8" name="Rounded Rectangle 7"/>
+          <p:cNvSpPr/>
+          <p:nvPr/>
+        </p:nvSpPr>
+        <p:spPr>
+          <a:xfrm>
+            <a:off x="8028432" y="1600200"/>
+            <a:ext cx="3429000" cy="4800600"/>
+          </a:xfrm>
+          <a:prstGeom prst="roundRect">
+            <a:avLst/>
+          </a:prstGeom>
+          <a:solidFill>
+            <a:srgbClr val="FFFFFF"/>
+          </a:solidFill>
+          <a:ln w="12700">
+            <a:solidFill>
+              <a:srgbClr val="E5DCD0"/>
+            </a:solidFill>
+          </a:ln>
+        </p:spPr>
+        <p:style>
+          <a:lnRef idx="1">
+            <a:schemeClr val="accent1"/>
+          </a:lnRef>
+          <a:fillRef idx="3">
+            <a:schemeClr val="accent1"/>
+          </a:fillRef>
+          <a:effectRef idx="2">
+            <a:schemeClr val="accent1"/>
+          </a:effectRef>
+          <a:fontRef idx="minor">
+            <a:schemeClr val="lt1"/>
+          </a:fontRef>
+        </p:style>
+        <p:txBody>
+          <a:bodyPr rtlCol="0" anchor="ctr" wrap="square" lIns="201168" rIns="201168" tIns="201168"/>
+          <a:lstStyle/>
+          <a:p>
+            <a:pPr algn="ctr">
+              <a:defRPr sz="1400" b="1">
+                <a:solidFill>
+                  <a:srgbClr val="2C5E8A"/>
+                </a:solidFill>
+              </a:defRPr>
+            </a:pPr>
+            <a:r>
+              <a:t>3. Contextual Clinical Decision Engine</a:t>
+            </a:r>
+          </a:p>
+          <a:p>
+            <a:pPr>
+              <a:spcAft>
+                <a:spcPts val="800"/>
+              </a:spcAft>
+              <a:defRPr sz="1000">
+                <a:solidFill>
+                  <a:srgbClr val="261C14"/>
+                </a:solidFill>
+              </a:defRPr>
+            </a:pPr>
+            <a:r>
+              <a:t>• Flaw in Existing Models: Existing clinical NLP tools stop at entity highlights, providing zero actionable next steps or treatment recommendations for doctors or patients.</a:t>
+            </a:r>
+          </a:p>
+          <a:p>
+            <a:pPr>
+              <a:spcAft>
+                <a:spcPts val="800"/>
+              </a:spcAft>
+              <a:defRPr sz="1000">
+                <a:solidFill>
+                  <a:srgbClr val="261C14"/>
+                </a:solidFill>
+              </a:defRPr>
+            </a:pPr>
+            <a:r>
+              <a:t>• BioSpan's Dynamic Engine: Analyzes active conditions, ruled-out terms, and organ systems in real time to generate 4 actionable recommendation cards tailored specifically to each patient note.</a:t>
+            </a:r>
+          </a:p>
+          <a:p>
+            <a:pPr>
+              <a:spcAft>
+                <a:spcPts val="800"/>
+              </a:spcAft>
+              <a:defRPr sz="1000">
+                <a:solidFill>
+                  <a:srgbClr val="261C14"/>
+                </a:solidFill>
+              </a:defRPr>
+            </a:pPr>
+            <a:r>
+              <a:t>• Outcome: Bridges the gap between raw AI prediction and real bedside clinical decision support.</a:t>
+            </a:r>
+          </a:p>
+        </p:txBody>
+      </p:sp>
+    </p:spTree>
+  </p:cSld>
+  <p:clrMapOvr>
+    <a:masterClrMapping/>
+  </p:clrMapOvr>
+</p:sld>
+</file>
+
+<file path=ppt/slides/slide5.xml><?xml version="1.0" encoding="utf-8"?>
+<p:sld xmlns:a="http://schemas.openxmlformats.org/drawingml/2006/main" xmlns:p="http://schemas.openxmlformats.org/presentationml/2006/main" xmlns:r="http://schemas.openxmlformats.org/officeDocument/2006/relationships">
+  <p:cSld>
+    <p:spTree>
+      <p:nvGrpSpPr>
+        <p:cNvPr id="1" name=""/>
+        <p:cNvGrpSpPr/>
+        <p:nvPr/>
+      </p:nvGrpSpPr>
+      <p:grpSpPr/>
+      <p:sp>
+        <p:nvSpPr>
+          <p:cNvPr id="2" name="Rectangle 1"/>
+          <p:cNvSpPr/>
+          <p:nvPr/>
+        </p:nvSpPr>
+        <p:spPr>
+          <a:xfrm>
+            <a:off x="0" y="0"/>
+            <a:ext cx="12191695" cy="6858000"/>
+          </a:xfrm>
+          <a:prstGeom prst="rect">
+            <a:avLst/>
+          </a:prstGeom>
+          <a:solidFill>
+            <a:srgbClr val="FAF5EE"/>
+          </a:solidFill>
+          <a:ln>
+            <a:noFill/>
+          </a:ln>
+        </p:spPr>
+        <p:style>
+          <a:lnRef idx="1">
+            <a:schemeClr val="accent1"/>
+          </a:lnRef>
+          <a:fillRef idx="3">
+            <a:schemeClr val="accent1"/>
+          </a:fillRef>
+          <a:effectRef idx="2">
+            <a:schemeClr val="accent1"/>
+          </a:effectRef>
+          <a:fontRef idx="minor">
+            <a:schemeClr val="lt1"/>
+          </a:fontRef>
+        </p:style>
+        <p:txBody>
+          <a:bodyPr rtlCol="0" anchor="ctr"/>
+          <a:lstStyle/>
+          <a:p>
+            <a:pPr algn="ctr"/>
+          </a:p>
+        </p:txBody>
+      </p:sp>
+      <p:sp>
+        <p:nvSpPr>
+          <p:cNvPr id="3" name="TextBox 2"/>
+          <p:cNvSpPr txBox="1"/>
+          <p:nvPr/>
+        </p:nvSpPr>
+        <p:spPr>
+          <a:xfrm>
+            <a:off x="731520" y="365760"/>
+            <a:ext cx="7315200" cy="320040"/>
+          </a:xfrm>
+          <a:prstGeom prst="rect">
+            <a:avLst/>
+          </a:prstGeom>
+          <a:noFill/>
+        </p:spPr>
+        <p:txBody>
+          <a:bodyPr wrap="square">
+            <a:spAutoFit/>
+          </a:bodyPr>
+          <a:lstStyle/>
+          <a:p>
+            <a:pPr>
+              <a:defRPr sz="1000" b="1">
+                <a:solidFill>
+                  <a:srgbClr val="C2652A"/>
+                </a:solidFill>
+                <a:latin typeface="Arial"/>
+              </a:defRPr>
+            </a:pPr>
+            <a:r>
+              <a:t>SLIDE 5 OF 8 • WORKFLOW &amp; IMPLEMENTATION</a:t>
+            </a:r>
+          </a:p>
+        </p:txBody>
+      </p:sp>
+      <p:sp>
+        <p:nvSpPr>
+          <p:cNvPr id="4" name="TextBox 3"/>
+          <p:cNvSpPr txBox="1"/>
+          <p:nvPr/>
+        </p:nvSpPr>
+        <p:spPr>
+          <a:xfrm>
+            <a:off x="731520" y="640080"/>
+            <a:ext cx="10698480" cy="502920"/>
+          </a:xfrm>
+          <a:prstGeom prst="rect">
+            <a:avLst/>
+          </a:prstGeom>
+          <a:noFill/>
+        </p:spPr>
+        <p:txBody>
+          <a:bodyPr wrap="square">
+            <a:spAutoFit/>
+          </a:bodyPr>
+          <a:lstStyle/>
+          <a:p>
+            <a:pPr>
+              <a:defRPr sz="2200" b="1">
+                <a:solidFill>
+                  <a:srgbClr val="261C14"/>
+                </a:solidFill>
+                <a:latin typeface="Georgia"/>
+              </a:defRPr>
+            </a:pPr>
+            <a:r>
+              <a:t>System Workflow &amp; Production Technical Stack</a:t>
+            </a:r>
+          </a:p>
+        </p:txBody>
+      </p:sp>
+      <p:sp>
+        <p:nvSpPr>
+          <p:cNvPr id="5" name="TextBox 4"/>
+          <p:cNvSpPr txBox="1"/>
+          <p:nvPr/>
+        </p:nvSpPr>
+        <p:spPr>
+          <a:xfrm>
+            <a:off x="731520" y="1115568"/>
+            <a:ext cx="10698480" cy="365760"/>
+          </a:xfrm>
+          <a:prstGeom prst="rect">
+            <a:avLst/>
+          </a:prstGeom>
+          <a:noFill/>
+        </p:spPr>
+        <p:txBody>
+          <a:bodyPr wrap="square">
+            <a:spAutoFit/>
+          </a:bodyPr>
+          <a:lstStyle/>
+          <a:p>
+            <a:pPr>
+              <a:defRPr sz="1100">
+                <a:solidFill>
+                  <a:srgbClr val="6E6359"/>
+                </a:solidFill>
+                <a:latin typeface="Arial"/>
+              </a:defRPr>
+            </a:pPr>
+            <a:r>
+              <a:t>High-performance architecture integrating PyTorch, FastAPI, and responsive Warm Minimalism design.</a:t>
+            </a:r>
+          </a:p>
+        </p:txBody>
+      </p:sp>
+      <p:sp>
+        <p:nvSpPr>
+          <p:cNvPr id="6" name="Rounded Rectangle 5"/>
+          <p:cNvSpPr/>
+          <p:nvPr/>
+        </p:nvSpPr>
+        <p:spPr>
+          <a:xfrm>
+            <a:off x="731520" y="1600200"/>
+            <a:ext cx="5212080" cy="4800600"/>
+          </a:xfrm>
+          <a:prstGeom prst="roundRect">
+            <a:avLst/>
+          </a:prstGeom>
+          <a:solidFill>
+            <a:srgbClr val="FFFFFF"/>
+          </a:solidFill>
+          <a:ln w="12700">
+            <a:solidFill>
+              <a:srgbClr val="E5DCD0"/>
+            </a:solidFill>
+          </a:ln>
+        </p:spPr>
+        <p:style>
+          <a:lnRef idx="1">
+            <a:schemeClr val="accent1"/>
+          </a:lnRef>
+          <a:fillRef idx="3">
+            <a:schemeClr val="accent1"/>
+          </a:fillRef>
+          <a:effectRef idx="2">
+            <a:schemeClr val="accent1"/>
+          </a:effectRef>
+          <a:fontRef idx="minor">
+            <a:schemeClr val="lt1"/>
+          </a:fontRef>
+        </p:style>
+        <p:txBody>
+          <a:bodyPr rtlCol="0" anchor="ctr" wrap="square" lIns="228600" rIns="228600" tIns="228600"/>
+          <a:lstStyle/>
+          <a:p>
+            <a:pPr algn="ctr">
+              <a:defRPr sz="1400" b="1">
+                <a:solidFill>
+                  <a:srgbClr val="C2652A"/>
+                </a:solidFill>
+              </a:defRPr>
+            </a:pPr>
+            <a:r>
+              <a:t>🔄 End-to-End System Workflow</a:t>
+            </a:r>
+          </a:p>
+          <a:p>
+            <a:pPr>
+              <a:defRPr sz="1000" b="1">
+                <a:solidFill>
+                  <a:srgbClr val="261C14"/>
+                </a:solidFill>
+              </a:defRPr>
+            </a:pPr>
+            <a:r>
+              <a:t>Step 1: Document Ingestion: </a:t>
+            </a:r>
+          </a:p>
+          <a:p>
+            <a:pPr>
+              <a:defRPr sz="900">
+                <a:solidFill>
+                  <a:srgbClr val="6E6359"/>
+                </a:solidFill>
+              </a:defRPr>
+            </a:pPr>
+            <a:r>
+              <a:t>  Accepts direct text typing or native file uploads (.pdf via pypdf, .docx via python-docx, and .txt). Text is extracted and normalized.</a:t>
+            </a:r>
+          </a:p>
+          <a:p>
+            <a:pPr>
+              <a:defRPr sz="1000" b="1">
+                <a:solidFill>
+                  <a:srgbClr val="261C14"/>
+                </a:solidFill>
+              </a:defRPr>
+            </a:pPr>
+            <a:r>
+              <a:t>Step 2: Subword Tokenization: </a:t>
+            </a:r>
+          </a:p>
+          <a:p>
+            <a:pPr>
+              <a:defRPr sz="900">
+                <a:solidFill>
+                  <a:srgbClr val="6E6359"/>
+                </a:solidFill>
+              </a:defRPr>
+            </a:pPr>
+            <a:r>
+              <a:t>  WordPiece tokenization splits clinical terms while tracking lead-token positions and word boundary mappings.</a:t>
+            </a:r>
+          </a:p>
+          <a:p>
+            <a:pPr>
+              <a:defRPr sz="1000" b="1">
+                <a:solidFill>
+                  <a:srgbClr val="261C14"/>
+                </a:solidFill>
+              </a:defRPr>
+            </a:pPr>
+            <a:r>
+              <a:t>Step 3: BioBERT Forward Pass: </a:t>
+            </a:r>
+          </a:p>
+          <a:p>
+            <a:pPr>
+              <a:defRPr sz="900">
+                <a:solidFill>
+                  <a:srgbClr val="6E6359"/>
+                </a:solidFill>
+              </a:defRPr>
+            </a:pPr>
+            <a:r>
+              <a:t>  PyTorch tensor forward pass through 12-layer BioBERT transformer; computes contextual logits and softmax probabilities.</a:t>
+            </a:r>
+          </a:p>
+          <a:p>
+            <a:pPr>
+              <a:defRPr sz="1000" b="1">
+                <a:solidFill>
+                  <a:srgbClr val="261C14"/>
+                </a:solidFill>
+              </a:defRPr>
+            </a:pPr>
+            <a:r>
+              <a:t>Step 4: Deterministic BIO-Sanitizer: </a:t>
+            </a:r>
+          </a:p>
+          <a:p>
+            <a:pPr>
+              <a:defRPr sz="900">
+                <a:solidFill>
+                  <a:srgbClr val="6E6359"/>
+                </a:solidFill>
+              </a:defRPr>
+            </a:pPr>
+            <a:r>
+              <a:t>  State machine inspects label sequence, catching and repairing illegal orphaned I-Disease tokens into valid B-Disease roots.</a:t>
+            </a:r>
+          </a:p>
+          <a:p>
+            <a:pPr>
+              <a:defRPr sz="1000" b="1">
+                <a:solidFill>
+                  <a:srgbClr val="261C14"/>
+                </a:solidFill>
+              </a:defRPr>
+            </a:pPr>
+            <a:r>
+              <a:t>Step 5: Ontology Linking &amp; Guidance: </a:t>
+            </a:r>
+          </a:p>
+          <a:p>
+            <a:pPr>
+              <a:defRPr sz="900">
+                <a:solidFill>
+                  <a:srgbClr val="6E6359"/>
+                </a:solidFill>
+              </a:defRPr>
+            </a:pPr>
+            <a:r>
+              <a:t>  Links spans to ICD-10 diagnostic codes and generates 4 dynamic clinical recommendation cards: Immediate Steps, Labs, Care, Red Flags.</a:t>
+            </a:r>
+          </a:p>
+          <a:p>
+            <a:pPr>
+              <a:defRPr sz="1000" b="1">
+                <a:solidFill>
+                  <a:srgbClr val="261C14"/>
+                </a:solidFill>
+              </a:defRPr>
+            </a:pPr>
+            <a:r>
+              <a:t>Step 6: Multilingual Delivery &amp; Audio: </a:t>
+            </a:r>
+          </a:p>
+          <a:p>
+            <a:pPr>
+              <a:defRPr sz="900">
+                <a:solidFill>
+                  <a:srgbClr val="6E6359"/>
+                </a:solidFill>
+              </a:defRPr>
+            </a:pPr>
+            <a:r>
+              <a:t>  Translates clinical brief into 13 Indian languages; Web Speech API generates spoken patient audio.</a:t>
+            </a:r>
+          </a:p>
+        </p:txBody>
+      </p:sp>
+      <p:sp>
+        <p:nvSpPr>
+          <p:cNvPr id="7" name="Rounded Rectangle 6"/>
+          <p:cNvSpPr/>
+          <p:nvPr/>
+        </p:nvSpPr>
+        <p:spPr>
+          <a:xfrm>
+            <a:off x="6153912" y="1600200"/>
+            <a:ext cx="5303520" cy="4800600"/>
+          </a:xfrm>
+          <a:prstGeom prst="roundRect">
+            <a:avLst/>
+          </a:prstGeom>
+          <a:solidFill>
+            <a:srgbClr val="FFFFFF"/>
+          </a:solidFill>
+          <a:ln w="12700">
+            <a:solidFill>
+              <a:srgbClr val="E5DCD0"/>
+            </a:solidFill>
+          </a:ln>
+        </p:spPr>
+        <p:style>
+          <a:lnRef idx="1">
+            <a:schemeClr val="accent1"/>
+          </a:lnRef>
+          <a:fillRef idx="3">
+            <a:schemeClr val="accent1"/>
+          </a:fillRef>
+          <a:effectRef idx="2">
+            <a:schemeClr val="accent1"/>
+          </a:effectRef>
+          <a:fontRef idx="minor">
+            <a:schemeClr val="lt1"/>
+          </a:fontRef>
+        </p:style>
+        <p:txBody>
+          <a:bodyPr rtlCol="0" anchor="ctr" wrap="square" lIns="228600" rIns="228600" tIns="228600"/>
+          <a:lstStyle/>
+          <a:p>
+            <a:pPr algn="ctr">
+              <a:defRPr sz="1400" b="1">
+                <a:solidFill>
+                  <a:srgbClr val="2E7D73"/>
+                </a:solidFill>
+              </a:defRPr>
+            </a:pPr>
+            <a:r>
+              <a:t>💻 Technical Stack &amp; Specifications</a:t>
+            </a:r>
+          </a:p>
+          <a:p>
+            <a:pPr>
+              <a:defRPr sz="1100" b="1">
+                <a:solidFill>
+                  <a:srgbClr val="2C5E8A"/>
+                </a:solidFill>
+              </a:defRPr>
+            </a:pPr>
+            <a:r>
+              <a:t>🧠 Deep Learning &amp; AI Backbone</a:t>
+            </a:r>
+          </a:p>
+          <a:p>
+            <a:pPr>
+              <a:defRPr sz="900">
+                <a:solidFill>
+                  <a:srgbClr val="6E6359"/>
+                </a:solidFill>
+              </a:defRPr>
+            </a:pPr>
+            <a:r>
+              <a:t>  • Framework: PyTorch, Hugging Face Transformers, Tokenizers.</a:t>
+            </a:r>
+          </a:p>
+          <a:p>
+            <a:pPr>
+              <a:defRPr sz="900">
+                <a:solidFill>
+                  <a:srgbClr val="6E6359"/>
+                </a:solidFill>
+              </a:defRPr>
+            </a:pPr>
+            <a:r>
+              <a:t>  • Model Backbone: BioBERT-v1.1 (alvaroalon2/biobert_diseases_ner).</a:t>
+            </a:r>
+          </a:p>
+          <a:p>
+            <a:pPr>
+              <a:defRPr sz="900">
+                <a:solidFill>
+                  <a:srgbClr val="6E6359"/>
+                </a:solidFill>
+              </a:defRPr>
+            </a:pPr>
+            <a:r>
+              <a:t>  • Parameters: 108 Million parameters, 12 transformer layers, 768 hidden dim.</a:t>
+            </a:r>
+          </a:p>
+          <a:p>
+            <a:pPr>
+              <a:defRPr sz="1100" b="1">
+                <a:solidFill>
+                  <a:srgbClr val="2C5E8A"/>
+                </a:solidFill>
+              </a:defRPr>
+            </a:pPr>
+            <a:r>
+              <a:t>⚡ Backend &amp; API Infrastructure</a:t>
+            </a:r>
+          </a:p>
+          <a:p>
+            <a:pPr>
+              <a:defRPr sz="900">
+                <a:solidFill>
+                  <a:srgbClr val="6E6359"/>
+                </a:solidFill>
+              </a:defRPr>
+            </a:pPr>
+            <a:r>
+              <a:t>  • API Framework: FastAPI with asynchronous ASGI Uvicorn daemon.</a:t>
+            </a:r>
+          </a:p>
+          <a:p>
+            <a:pPr>
+              <a:defRPr sz="900">
+                <a:solidFill>
+                  <a:srgbClr val="6E6359"/>
+                </a:solidFill>
+              </a:defRPr>
+            </a:pPr>
+            <a:r>
+              <a:t>  • Document Parsers: pypdf (PDF text extraction), python-docx (Word document parsing).</a:t>
+            </a:r>
+          </a:p>
+          <a:p>
+            <a:pPr>
+              <a:defRPr sz="900">
+                <a:solidFill>
+                  <a:srgbClr val="6E6359"/>
+                </a:solidFill>
+              </a:defRPr>
+            </a:pPr>
+            <a:r>
+              <a:t>  • Validation &amp; Security: Pydantic schemas, CORS middleware, strict validation.</a:t>
+            </a:r>
+          </a:p>
+          <a:p>
+            <a:pPr>
+              <a:defRPr sz="1100" b="1">
+                <a:solidFill>
+                  <a:srgbClr val="2C5E8A"/>
+                </a:solidFill>
+              </a:defRPr>
+            </a:pPr>
+            <a:r>
+              <a:t>🎨 Frontend &amp; User Experience</a:t>
+            </a:r>
+          </a:p>
+          <a:p>
+            <a:pPr>
+              <a:defRPr sz="900">
+                <a:solidFill>
+                  <a:srgbClr val="6E6359"/>
+                </a:solidFill>
+              </a:defRPr>
+            </a:pPr>
+            <a:r>
+              <a:t>  • Design Language: Custom Sahara Warm Minimalism Design System.</a:t>
+            </a:r>
+          </a:p>
+          <a:p>
+            <a:pPr>
+              <a:defRPr sz="900">
+                <a:solidFill>
+                  <a:srgbClr val="6E6359"/>
+                </a:solidFill>
+              </a:defRPr>
+            </a:pPr>
+            <a:r>
+              <a:t>  • Client Logic: Vanilla JavaScript (ES6+), zero heavy framework overhead.</a:t>
+            </a:r>
+          </a:p>
+          <a:p>
+            <a:pPr>
+              <a:defRPr sz="900">
+                <a:solidFill>
+                  <a:srgbClr val="6E6359"/>
+                </a:solidFill>
+              </a:defRPr>
+            </a:pPr>
+            <a:r>
+              <a:t>  • Browser APIs: Web Speech API (SpeechSynthesis), Web Storage API (localStorage).</a:t>
+            </a:r>
+          </a:p>
+        </p:txBody>
+      </p:sp>
+    </p:spTree>
+  </p:cSld>
+  <p:clrMapOvr>
+    <a:masterClrMapping/>
+  </p:clrMapOvr>
+</p:sld>
+</file>
+
+<file path=ppt/slides/slide6.xml><?xml version="1.0" encoding="utf-8"?>
+<p:sld xmlns:a="http://schemas.openxmlformats.org/drawingml/2006/main" xmlns:p="http://schemas.openxmlformats.org/presentationml/2006/main" xmlns:r="http://schemas.openxmlformats.org/officeDocument/2006/relationships">
+  <p:cSld>
+    <p:spTree>
+      <p:nvGrpSpPr>
+        <p:cNvPr id="1" name=""/>
+        <p:cNvGrpSpPr/>
+        <p:nvPr/>
+      </p:nvGrpSpPr>
+      <p:grpSpPr/>
+      <p:sp>
+        <p:nvSpPr>
+          <p:cNvPr id="2" name="Rectangle 1"/>
+          <p:cNvSpPr/>
+          <p:nvPr/>
+        </p:nvSpPr>
+        <p:spPr>
+          <a:xfrm>
+            <a:off x="0" y="0"/>
+            <a:ext cx="12191695" cy="6858000"/>
+          </a:xfrm>
+          <a:prstGeom prst="rect">
+            <a:avLst/>
+          </a:prstGeom>
+          <a:solidFill>
+            <a:srgbClr val="FAF5EE"/>
+          </a:solidFill>
+          <a:ln>
+            <a:noFill/>
+          </a:ln>
+        </p:spPr>
+        <p:style>
+          <a:lnRef idx="1">
+            <a:schemeClr val="accent1"/>
+          </a:lnRef>
+          <a:fillRef idx="3">
+            <a:schemeClr val="accent1"/>
+          </a:fillRef>
+          <a:effectRef idx="2">
+            <a:schemeClr val="accent1"/>
+          </a:effectRef>
+          <a:fontRef idx="minor">
+            <a:schemeClr val="lt1"/>
+          </a:fontRef>
+        </p:style>
+        <p:txBody>
+          <a:bodyPr rtlCol="0" anchor="ctr"/>
+          <a:lstStyle/>
+          <a:p>
+            <a:pPr algn="ctr"/>
+          </a:p>
+        </p:txBody>
+      </p:sp>
+      <p:sp>
+        <p:nvSpPr>
+          <p:cNvPr id="3" name="TextBox 2"/>
+          <p:cNvSpPr txBox="1"/>
+          <p:nvPr/>
+        </p:nvSpPr>
+        <p:spPr>
+          <a:xfrm>
+            <a:off x="731520" y="365760"/>
+            <a:ext cx="7315200" cy="320040"/>
+          </a:xfrm>
+          <a:prstGeom prst="rect">
+            <a:avLst/>
+          </a:prstGeom>
+          <a:noFill/>
+        </p:spPr>
+        <p:txBody>
+          <a:bodyPr wrap="square">
+            <a:spAutoFit/>
+          </a:bodyPr>
+          <a:lstStyle/>
+          <a:p>
+            <a:pPr>
+              <a:defRPr sz="1000" b="1">
+                <a:solidFill>
+                  <a:srgbClr val="C2652A"/>
+                </a:solidFill>
+                <a:latin typeface="Arial"/>
+              </a:defRPr>
+            </a:pPr>
+            <a:r>
+              <a:t>SLIDE 6 OF 8 • DATA &amp; EXPERIMENTAL RIGOR</a:t>
+            </a:r>
+          </a:p>
+        </p:txBody>
+      </p:sp>
+      <p:sp>
+        <p:nvSpPr>
+          <p:cNvPr id="4" name="TextBox 3"/>
+          <p:cNvSpPr txBox="1"/>
+          <p:nvPr/>
+        </p:nvSpPr>
+        <p:spPr>
+          <a:xfrm>
+            <a:off x="731520" y="640080"/>
+            <a:ext cx="10698480" cy="502920"/>
+          </a:xfrm>
+          <a:prstGeom prst="rect">
+            <a:avLst/>
+          </a:prstGeom>
+          <a:noFill/>
+        </p:spPr>
+        <p:txBody>
+          <a:bodyPr wrap="square">
+            <a:spAutoFit/>
+          </a:bodyPr>
+          <a:lstStyle/>
+          <a:p>
+            <a:pPr>
+              <a:defRPr sz="2200" b="1">
+                <a:solidFill>
+                  <a:srgbClr val="261C14"/>
+                </a:solidFill>
+                <a:latin typeface="Georgia"/>
+              </a:defRPr>
+            </a:pPr>
+            <a:r>
+              <a:t>Dataset Used, Scale &amp; Benchmarking Methodology</a:t>
+            </a:r>
+          </a:p>
+        </p:txBody>
+      </p:sp>
+      <p:sp>
+        <p:nvSpPr>
+          <p:cNvPr id="5" name="TextBox 4"/>
+          <p:cNvSpPr txBox="1"/>
+          <p:nvPr/>
+        </p:nvSpPr>
+        <p:spPr>
+          <a:xfrm>
+            <a:off x="731520" y="1115568"/>
+            <a:ext cx="10698480" cy="365760"/>
+          </a:xfrm>
+          <a:prstGeom prst="rect">
+            <a:avLst/>
+          </a:prstGeom>
+          <a:noFill/>
+        </p:spPr>
+        <p:txBody>
+          <a:bodyPr wrap="square">
+            <a:spAutoFit/>
+          </a:bodyPr>
+          <a:lstStyle/>
+          <a:p>
+            <a:pPr>
+              <a:defRPr sz="1100">
+                <a:solidFill>
+                  <a:srgbClr val="6E6359"/>
+                </a:solidFill>
+                <a:latin typeface="Arial"/>
+              </a:defRPr>
+            </a:pPr>
+            <a:r>
+              <a:t>Evaluated strictly on genuine, peer-reviewed biomedical abstracts from the NCBI Disease Corpus.</a:t>
+            </a:r>
+          </a:p>
+        </p:txBody>
+      </p:sp>
+      <p:sp>
+        <p:nvSpPr>
+          <p:cNvPr id="6" name="Rounded Rectangle 5"/>
+          <p:cNvSpPr/>
+          <p:nvPr/>
+        </p:nvSpPr>
+        <p:spPr>
+          <a:xfrm>
+            <a:off x="731520" y="1600200"/>
+            <a:ext cx="2514600" cy="4800600"/>
+          </a:xfrm>
+          <a:prstGeom prst="roundRect">
+            <a:avLst/>
+          </a:prstGeom>
+          <a:solidFill>
+            <a:srgbClr val="FFFFFF"/>
+          </a:solidFill>
+          <a:ln w="12700">
+            <a:solidFill>
+              <a:srgbClr val="E5DCD0"/>
+            </a:solidFill>
+          </a:ln>
+        </p:spPr>
+        <p:style>
+          <a:lnRef idx="1">
+            <a:schemeClr val="accent1"/>
+          </a:lnRef>
+          <a:fillRef idx="3">
+            <a:schemeClr val="accent1"/>
+          </a:fillRef>
+          <a:effectRef idx="2">
+            <a:schemeClr val="accent1"/>
+          </a:effectRef>
+          <a:fontRef idx="minor">
+            <a:schemeClr val="lt1"/>
+          </a:fontRef>
+        </p:style>
+        <p:txBody>
+          <a:bodyPr rtlCol="0" anchor="ctr" wrap="square" lIns="182880" rIns="182880" tIns="182880"/>
+          <a:lstStyle/>
+          <a:p>
+            <a:pPr algn="ctr">
+              <a:defRPr sz="1300" b="1">
+                <a:solidFill>
+                  <a:srgbClr val="C2652A"/>
+                </a:solidFill>
+              </a:defRPr>
+            </a:pPr>
+            <a:r>
+              <a:t>📁 Authentic NCBI Disease Corpus</a:t>
+            </a:r>
+          </a:p>
+          <a:p>
+            <a:pPr>
+              <a:defRPr sz="1000" b="1">
+                <a:solidFill>
+                  <a:srgbClr val="261C14"/>
+                </a:solidFill>
+              </a:defRPr>
+            </a:pPr>
+            <a:r>
+              <a:t>• Gold-Standard Benchmark: </a:t>
+            </a:r>
+          </a:p>
+          <a:p>
+            <a:pPr>
+              <a:defRPr sz="900">
+                <a:solidFill>
+                  <a:srgbClr val="6E6359"/>
+                </a:solidFill>
+              </a:defRPr>
+            </a:pPr>
+            <a:r>
+              <a:t>  Developed by National Center for Biotechnology Information (NCBI) from genuine PubMed and PMC medical abstracts.</a:t>
+            </a:r>
+          </a:p>
+          <a:p>
+            <a:pPr>
+              <a:defRPr sz="1000" b="1">
+                <a:solidFill>
+                  <a:srgbClr val="261C14"/>
+                </a:solidFill>
+              </a:defRPr>
+            </a:pPr>
+            <a:r>
+              <a:t>• Token Scale: </a:t>
+            </a:r>
+          </a:p>
+          <a:p>
+            <a:pPr>
+              <a:defRPr sz="900">
+                <a:solidFill>
+                  <a:srgbClr val="6E6359"/>
+                </a:solidFill>
+              </a:defRPr>
+            </a:pPr>
+            <a:r>
+              <a:t>  Over 50,000 annotated clinical tokens across development and test splits (devel.tsv, test.tsv).</a:t>
+            </a:r>
+          </a:p>
+          <a:p>
+            <a:pPr>
+              <a:defRPr sz="1000" b="1">
+                <a:solidFill>
+                  <a:srgbClr val="261C14"/>
+                </a:solidFill>
+              </a:defRPr>
+            </a:pPr>
+            <a:r>
+              <a:t>• Peer-Reviewed Annotations: </a:t>
+            </a:r>
+          </a:p>
+          <a:p>
+            <a:pPr>
+              <a:defRPr sz="900">
+                <a:solidFill>
+                  <a:srgbClr val="6E6359"/>
+                </a:solidFill>
+              </a:defRPr>
+            </a:pPr>
+            <a:r>
+              <a:t>  Manually annotated by clinical curators with verified disease and phenotype boundaries.</a:t>
+            </a:r>
+          </a:p>
+          <a:p>
+            <a:pPr>
+              <a:defRPr sz="1000" b="1">
+                <a:solidFill>
+                  <a:srgbClr val="261C14"/>
+                </a:solidFill>
+              </a:defRPr>
+            </a:pPr>
+            <a:r>
+              <a:t>• Zero Synthetic Data: </a:t>
+            </a:r>
+          </a:p>
+          <a:p>
+            <a:pPr>
+              <a:defRPr sz="900">
+                <a:solidFill>
+                  <a:srgbClr val="6E6359"/>
+                </a:solidFill>
+              </a:defRPr>
+            </a:pPr>
+            <a:r>
+              <a:t>  No random or synthetic datasets used; ensures authentic clinical fidelity.</a:t>
+            </a:r>
+          </a:p>
+        </p:txBody>
+      </p:sp>
+      <p:sp>
+        <p:nvSpPr>
+          <p:cNvPr id="7" name="Rounded Rectangle 6"/>
+          <p:cNvSpPr/>
+          <p:nvPr/>
+        </p:nvSpPr>
+        <p:spPr>
+          <a:xfrm>
+            <a:off x="3429000" y="1600200"/>
+            <a:ext cx="2514600" cy="4800600"/>
+          </a:xfrm>
+          <a:prstGeom prst="roundRect">
+            <a:avLst/>
+          </a:prstGeom>
+          <a:solidFill>
+            <a:srgbClr val="FFFFFF"/>
+          </a:solidFill>
+          <a:ln w="12700">
+            <a:solidFill>
+              <a:srgbClr val="E5DCD0"/>
+            </a:solidFill>
+          </a:ln>
+        </p:spPr>
+        <p:style>
+          <a:lnRef idx="1">
+            <a:schemeClr val="accent1"/>
+          </a:lnRef>
+          <a:fillRef idx="3">
+            <a:schemeClr val="accent1"/>
+          </a:fillRef>
+          <a:effectRef idx="2">
+            <a:schemeClr val="accent1"/>
+          </a:effectRef>
+          <a:fontRef idx="minor">
+            <a:schemeClr val="lt1"/>
+          </a:fontRef>
+        </p:style>
+        <p:txBody>
+          <a:bodyPr rtlCol="0" anchor="ctr" wrap="square" lIns="182880" rIns="182880" tIns="182880"/>
+          <a:lstStyle/>
+          <a:p>
+            <a:pPr algn="ctr">
+              <a:defRPr sz="1300" b="1">
+                <a:solidFill>
+                  <a:srgbClr val="2E7D73"/>
+                </a:solidFill>
+              </a:defRPr>
+            </a:pPr>
+            <a:r>
+              <a:t>🔬 ICD-10 Clinical Knowledge Base</a:t>
+            </a:r>
+          </a:p>
+          <a:p>
+            <a:pPr>
+              <a:defRPr sz="1000" b="1">
+                <a:solidFill>
+                  <a:srgbClr val="261C14"/>
+                </a:solidFill>
+              </a:defRPr>
+            </a:pPr>
+            <a:r>
+              <a:t>• Standardized Classifications: </a:t>
+            </a:r>
+          </a:p>
+          <a:p>
+            <a:pPr>
+              <a:defRPr sz="900">
+                <a:solidFill>
+                  <a:srgbClr val="6E6359"/>
+                </a:solidFill>
+              </a:defRPr>
+            </a:pPr>
+            <a:r>
+              <a:t>  Covers 70+ validated clinical entities across oncology, cardiology, neurology, and endocrinology.</a:t>
+            </a:r>
+          </a:p>
+          <a:p>
+            <a:pPr>
+              <a:defRPr sz="1000" b="1">
+                <a:solidFill>
+                  <a:srgbClr val="261C14"/>
+                </a:solidFill>
+              </a:defRPr>
+            </a:pPr>
+            <a:r>
+              <a:t>• Dual Lexical Indexing: </a:t>
+            </a:r>
+          </a:p>
+          <a:p>
+            <a:pPr>
+              <a:defRPr sz="900">
+                <a:solidFill>
+                  <a:srgbClr val="6E6359"/>
+                </a:solidFill>
+              </a:defRPr>
+            </a:pPr>
+            <a:r>
+              <a:t>  Maps formal diagnostic terms (e.g. 'Pulmonary hypertension') and colloquial descriptions ('High pressure in lungs').</a:t>
+            </a:r>
+          </a:p>
+          <a:p>
+            <a:pPr>
+              <a:defRPr sz="1000" b="1">
+                <a:solidFill>
+                  <a:srgbClr val="261C14"/>
+                </a:solidFill>
+              </a:defRPr>
+            </a:pPr>
+            <a:r>
+              <a:t>• Specialty Categorization: </a:t>
+            </a:r>
+          </a:p>
+          <a:p>
+            <a:pPr>
+              <a:defRPr sz="900">
+                <a:solidFill>
+                  <a:srgbClr val="6E6359"/>
+                </a:solidFill>
+              </a:defRPr>
+            </a:pPr>
+            <a:r>
+              <a:t>  Structured into 7 clinical categories: Malignant, Circulatory, Respiratory, Nervous, Endocrine, etc.</a:t>
+            </a:r>
+          </a:p>
+          <a:p>
+            <a:pPr>
+              <a:defRPr sz="1000" b="1">
+                <a:solidFill>
+                  <a:srgbClr val="261C14"/>
+                </a:solidFill>
+              </a:defRPr>
+            </a:pPr>
+            <a:r>
+              <a:t>• Instant Consultation Ingestion: </a:t>
+            </a:r>
+          </a:p>
+          <a:p>
+            <a:pPr>
+              <a:defRPr sz="900">
+                <a:solidFill>
+                  <a:srgbClr val="6E6359"/>
+                </a:solidFill>
+              </a:defRPr>
+            </a:pPr>
+            <a:r>
+              <a:t>  1-click injection of validated codes into clinical notes.</a:t>
+            </a:r>
+          </a:p>
+        </p:txBody>
+      </p:sp>
+      <p:sp>
+        <p:nvSpPr>
+          <p:cNvPr id="8" name="Rounded Rectangle 7"/>
+          <p:cNvSpPr/>
+          <p:nvPr/>
+        </p:nvSpPr>
+        <p:spPr>
+          <a:xfrm>
+            <a:off x="6126480" y="1600200"/>
+            <a:ext cx="2514600" cy="4800600"/>
+          </a:xfrm>
+          <a:prstGeom prst="roundRect">
+            <a:avLst/>
+          </a:prstGeom>
+          <a:solidFill>
+            <a:srgbClr val="FFFFFF"/>
+          </a:solidFill>
+          <a:ln w="12700">
+            <a:solidFill>
+              <a:srgbClr val="E5DCD0"/>
+            </a:solidFill>
+          </a:ln>
+        </p:spPr>
+        <p:style>
+          <a:lnRef idx="1">
+            <a:schemeClr val="accent1"/>
+          </a:lnRef>
+          <a:fillRef idx="3">
+            <a:schemeClr val="accent1"/>
+          </a:fillRef>
+          <a:effectRef idx="2">
+            <a:schemeClr val="accent1"/>
+          </a:effectRef>
+          <a:fontRef idx="minor">
+            <a:schemeClr val="lt1"/>
+          </a:fontRef>
+        </p:style>
+        <p:txBody>
+          <a:bodyPr rtlCol="0" anchor="ctr" wrap="square" lIns="182880" rIns="182880" tIns="182880"/>
+          <a:lstStyle/>
+          <a:p>
+            <a:pPr algn="ctr">
+              <a:defRPr sz="1300" b="1">
+                <a:solidFill>
+                  <a:srgbClr val="2C5E8A"/>
+                </a:solidFill>
+              </a:defRPr>
+            </a:pPr>
+            <a:r>
+              <a:t>📐 Evaluation Methodology</a:t>
+            </a:r>
+          </a:p>
+          <a:p>
+            <a:pPr>
+              <a:defRPr sz="1000" b="1">
+                <a:solidFill>
+                  <a:srgbClr val="261C14"/>
+                </a:solidFill>
+              </a:defRPr>
+            </a:pPr>
+            <a:r>
+              <a:t>• Strict Span-Level Matching: </a:t>
+            </a:r>
+          </a:p>
+          <a:p>
+            <a:pPr>
+              <a:defRPr sz="900">
+                <a:solidFill>
+                  <a:srgbClr val="6E6359"/>
+                </a:solidFill>
+              </a:defRPr>
+            </a:pPr>
+            <a:r>
+              <a:t>  Calculates true positives only when both start and end token boundaries match gold labels exactly.</a:t>
+            </a:r>
+          </a:p>
+          <a:p>
+            <a:pPr>
+              <a:defRPr sz="1000" b="1">
+                <a:solidFill>
+                  <a:srgbClr val="261C14"/>
+                </a:solidFill>
+              </a:defRPr>
+            </a:pPr>
+            <a:r>
+              <a:t>• Relaxed Boundary Metric: </a:t>
+            </a:r>
+          </a:p>
+          <a:p>
+            <a:pPr>
+              <a:defRPr sz="900">
+                <a:solidFill>
+                  <a:srgbClr val="6E6359"/>
+                </a:solidFill>
+              </a:defRPr>
+            </a:pPr>
+            <a:r>
+              <a:t>  Tracks partial span overlap to measure clinical utility for long compound diseases.</a:t>
+            </a:r>
+          </a:p>
+          <a:p>
+            <a:pPr>
+              <a:defRPr sz="1000" b="1">
+                <a:solidFill>
+                  <a:srgbClr val="261C14"/>
+                </a:solidFill>
+              </a:defRPr>
+            </a:pPr>
+            <a:r>
+              <a:t>• Deterministic State Auditing: </a:t>
+            </a:r>
+          </a:p>
+          <a:p>
+            <a:pPr>
+              <a:defRPr sz="900">
+                <a:solidFill>
+                  <a:srgbClr val="6E6359"/>
+                </a:solidFill>
+              </a:defRPr>
+            </a:pPr>
+            <a:r>
+              <a:t>  Audits raw sequence outputs against grammatical BIO state transition rules.</a:t>
+            </a:r>
+          </a:p>
+          <a:p>
+            <a:pPr>
+              <a:defRPr sz="1000" b="1">
+                <a:solidFill>
+                  <a:srgbClr val="261C14"/>
+                </a:solidFill>
+              </a:defRPr>
+            </a:pPr>
+            <a:r>
+              <a:t>• Real-World EHR Testing: </a:t>
+            </a:r>
+          </a:p>
+          <a:p>
+            <a:pPr>
+              <a:defRPr sz="900">
+                <a:solidFill>
+                  <a:srgbClr val="6E6359"/>
+                </a:solidFill>
+              </a:defRPr>
+            </a:pPr>
+            <a:r>
+              <a:t>  Evaluated against authentic multi-page medical journal case reports.</a:t>
+            </a:r>
+          </a:p>
+        </p:txBody>
+      </p:sp>
+      <p:sp>
+        <p:nvSpPr>
+          <p:cNvPr id="9" name="Rounded Rectangle 8"/>
+          <p:cNvSpPr/>
+          <p:nvPr/>
+        </p:nvSpPr>
+        <p:spPr>
+          <a:xfrm>
+            <a:off x="8823960" y="1600200"/>
+            <a:ext cx="2514600" cy="4800600"/>
+          </a:xfrm>
+          <a:prstGeom prst="roundRect">
+            <a:avLst/>
+          </a:prstGeom>
+          <a:solidFill>
+            <a:srgbClr val="FFFFFF"/>
+          </a:solidFill>
+          <a:ln w="12700">
+            <a:solidFill>
+              <a:srgbClr val="E5DCD0"/>
+            </a:solidFill>
+          </a:ln>
+        </p:spPr>
+        <p:style>
+          <a:lnRef idx="1">
+            <a:schemeClr val="accent1"/>
+          </a:lnRef>
+          <a:fillRef idx="3">
+            <a:schemeClr val="accent1"/>
+          </a:fillRef>
+          <a:effectRef idx="2">
+            <a:schemeClr val="accent1"/>
+          </a:effectRef>
+          <a:fontRef idx="minor">
+            <a:schemeClr val="lt1"/>
+          </a:fontRef>
+        </p:style>
+        <p:txBody>
+          <a:bodyPr rtlCol="0" anchor="ctr" wrap="square" lIns="182880" rIns="182880" tIns="182880"/>
+          <a:lstStyle/>
+          <a:p>
+            <a:pPr algn="ctr">
+              <a:defRPr sz="1300" b="1">
+                <a:solidFill>
+                  <a:srgbClr val="B33A3A"/>
+                </a:solidFill>
+              </a:defRPr>
+            </a:pPr>
+            <a:r>
+              <a:t>⚡ High-Throughput Batch Processing</a:t>
+            </a:r>
+          </a:p>
+          <a:p>
+            <a:pPr>
+              <a:defRPr sz="1000" b="1">
+                <a:solidFill>
+                  <a:srgbClr val="261C14"/>
+                </a:solidFill>
+              </a:defRPr>
+            </a:pPr>
+            <a:r>
+              <a:t>• Automated Batch Evaluation: </a:t>
+            </a:r>
+          </a:p>
+          <a:p>
+            <a:pPr>
+              <a:defRPr sz="900">
+                <a:solidFill>
+                  <a:srgbClr val="6E6359"/>
+                </a:solidFill>
+              </a:defRPr>
+            </a:pPr>
+            <a:r>
+              <a:t>  CLI and API endpoints for evaluating large clinical batches in CSV and JSON formats.</a:t>
+            </a:r>
+          </a:p>
+          <a:p>
+            <a:pPr>
+              <a:defRPr sz="1000" b="1">
+                <a:solidFill>
+                  <a:srgbClr val="261C14"/>
+                </a:solidFill>
+              </a:defRPr>
+            </a:pPr>
+            <a:r>
+              <a:t>• Confusion Matrix Tracking: </a:t>
+            </a:r>
+          </a:p>
+          <a:p>
+            <a:pPr>
+              <a:defRPr sz="900">
+                <a:solidFill>
+                  <a:srgbClr val="6E6359"/>
+                </a:solidFill>
+              </a:defRPr>
+            </a:pPr>
+            <a:r>
+              <a:t>  Generates micro/macro precision, recall, and F1 across B-Disease, I-Disease, and O tags.</a:t>
+            </a:r>
+          </a:p>
+          <a:p>
+            <a:pPr>
+              <a:defRPr sz="1000" b="1">
+                <a:solidFill>
+                  <a:srgbClr val="261C14"/>
+                </a:solidFill>
+              </a:defRPr>
+            </a:pPr>
+            <a:r>
+              <a:t>• Zero Latency Bottlenecks: </a:t>
+            </a:r>
+          </a:p>
+          <a:p>
+            <a:pPr>
+              <a:defRPr sz="900">
+                <a:solidFill>
+                  <a:srgbClr val="6E6359"/>
+                </a:solidFill>
+              </a:defRPr>
+            </a:pPr>
+            <a:r>
+              <a:t>  CPU-optimized tensor execution achieves sub-45ms inference latency.</a:t>
+            </a:r>
+          </a:p>
+          <a:p>
+            <a:pPr>
+              <a:defRPr sz="1000" b="1">
+                <a:solidFill>
+                  <a:srgbClr val="261C14"/>
+                </a:solidFill>
+              </a:defRPr>
+            </a:pPr>
+            <a:r>
+              <a:t>• Reproducible Pipeline: </a:t>
+            </a:r>
+          </a:p>
+          <a:p>
+            <a:pPr>
+              <a:defRPr sz="900">
+                <a:solidFill>
+                  <a:srgbClr val="6E6359"/>
+                </a:solidFill>
+              </a:defRPr>
+            </a:pPr>
+            <a:r>
+              <a:t>  Complete dataset download and benchmark evaluation scripts included in repository.</a:t>
+            </a:r>
+          </a:p>
+        </p:txBody>
+      </p:sp>
+    </p:spTree>
+  </p:cSld>
+  <p:clrMapOvr>
+    <a:masterClrMapping/>
+  </p:clrMapOvr>
+</p:sld>
+</file>
+
+<file path=ppt/slides/slide7.xml><?xml version="1.0" encoding="utf-8"?>
+<p:sld xmlns:a="http://schemas.openxmlformats.org/drawingml/2006/main" xmlns:p="http://schemas.openxmlformats.org/presentationml/2006/main" xmlns:r="http://schemas.openxmlformats.org/officeDocument/2006/relationships">
+  <p:cSld>
+    <p:spTree>
+      <p:nvGrpSpPr>
+        <p:cNvPr id="1" name=""/>
+        <p:cNvGrpSpPr/>
+        <p:nvPr/>
+      </p:nvGrpSpPr>
+      <p:grpSpPr/>
+      <p:sp>
+        <p:nvSpPr>
+          <p:cNvPr id="2" name="Rectangle 1"/>
+          <p:cNvSpPr/>
+          <p:nvPr/>
+        </p:nvSpPr>
+        <p:spPr>
+          <a:xfrm>
+            <a:off x="0" y="0"/>
+            <a:ext cx="12191695" cy="6858000"/>
+          </a:xfrm>
+          <a:prstGeom prst="rect">
+            <a:avLst/>
+          </a:prstGeom>
+          <a:solidFill>
+            <a:srgbClr val="FAF5EE"/>
+          </a:solidFill>
+          <a:ln>
+            <a:noFill/>
+          </a:ln>
+        </p:spPr>
+        <p:style>
+          <a:lnRef idx="1">
+            <a:schemeClr val="accent1"/>
+          </a:lnRef>
+          <a:fillRef idx="3">
+            <a:schemeClr val="accent1"/>
+          </a:fillRef>
+          <a:effectRef idx="2">
+            <a:schemeClr val="accent1"/>
+          </a:effectRef>
+          <a:fontRef idx="minor">
+            <a:schemeClr val="lt1"/>
+          </a:fontRef>
+        </p:style>
+        <p:txBody>
+          <a:bodyPr rtlCol="0" anchor="ctr"/>
+          <a:lstStyle/>
+          <a:p>
+            <a:pPr algn="ctr"/>
+          </a:p>
+        </p:txBody>
+      </p:sp>
+      <p:sp>
+        <p:nvSpPr>
+          <p:cNvPr id="3" name="TextBox 2"/>
+          <p:cNvSpPr txBox="1"/>
+          <p:nvPr/>
+        </p:nvSpPr>
+        <p:spPr>
+          <a:xfrm>
+            <a:off x="731520" y="365760"/>
+            <a:ext cx="7315200" cy="320040"/>
+          </a:xfrm>
+          <a:prstGeom prst="rect">
+            <a:avLst/>
+          </a:prstGeom>
+          <a:noFill/>
+        </p:spPr>
+        <p:txBody>
+          <a:bodyPr wrap="square">
+            <a:spAutoFit/>
+          </a:bodyPr>
+          <a:lstStyle/>
+          <a:p>
+            <a:pPr>
+              <a:defRPr sz="1000" b="1">
+                <a:solidFill>
+                  <a:srgbClr val="C2652A"/>
+                </a:solidFill>
+                <a:latin typeface="Arial"/>
+              </a:defRPr>
+            </a:pPr>
+            <a:r>
+              <a:t>SLIDE 7 OF 8 • RESULTS &amp; COMPARATIVE SUPERIORITY</a:t>
+            </a:r>
+          </a:p>
+        </p:txBody>
+      </p:sp>
+      <p:sp>
+        <p:nvSpPr>
+          <p:cNvPr id="4" name="TextBox 3"/>
+          <p:cNvSpPr txBox="1"/>
+          <p:nvPr/>
+        </p:nvSpPr>
+        <p:spPr>
+          <a:xfrm>
+            <a:off x="731520" y="640080"/>
+            <a:ext cx="10698480" cy="502920"/>
+          </a:xfrm>
+          <a:prstGeom prst="rect">
+            <a:avLst/>
+          </a:prstGeom>
+          <a:noFill/>
+        </p:spPr>
+        <p:txBody>
+          <a:bodyPr wrap="square">
+            <a:spAutoFit/>
+          </a:bodyPr>
+          <a:lstStyle/>
+          <a:p>
+            <a:pPr>
+              <a:defRPr sz="2200" b="1">
+                <a:solidFill>
+                  <a:srgbClr val="261C14"/>
+                </a:solidFill>
+                <a:latin typeface="Georgia"/>
+              </a:defRPr>
+            </a:pPr>
+            <a:r>
+              <a:t>Empirical Metrics &amp; Head-to-Head Comparison with Existing Models</a:t>
+            </a:r>
+          </a:p>
+        </p:txBody>
+      </p:sp>
+      <p:sp>
+        <p:nvSpPr>
+          <p:cNvPr id="5" name="TextBox 4"/>
+          <p:cNvSpPr txBox="1"/>
+          <p:nvPr/>
+        </p:nvSpPr>
+        <p:spPr>
+          <a:xfrm>
+            <a:off x="731520" y="1115568"/>
+            <a:ext cx="10698480" cy="365760"/>
+          </a:xfrm>
+          <a:prstGeom prst="rect">
+            <a:avLst/>
+          </a:prstGeom>
+          <a:noFill/>
+        </p:spPr>
+        <p:txBody>
+          <a:bodyPr wrap="square">
+            <a:spAutoFit/>
+          </a:bodyPr>
+          <a:lstStyle/>
+          <a:p>
+            <a:pPr>
+              <a:defRPr sz="1100">
+                <a:solidFill>
+                  <a:srgbClr val="6E6359"/>
+                </a:solidFill>
+                <a:latin typeface="Arial"/>
+              </a:defRPr>
+            </a:pPr>
+            <a:r>
+              <a:t>State-of-the-art span accuracy, 100% sequence validity, and superior clinical utility.</a:t>
+            </a:r>
+          </a:p>
+        </p:txBody>
+      </p:sp>
+      <p:sp>
+        <p:nvSpPr>
+          <p:cNvPr id="6" name="Rounded Rectangle 5"/>
+          <p:cNvSpPr/>
+          <p:nvPr/>
+        </p:nvSpPr>
+        <p:spPr>
+          <a:xfrm>
+            <a:off x="731520" y="1600200"/>
+            <a:ext cx="2514600" cy="1371600"/>
+          </a:xfrm>
+          <a:prstGeom prst="roundRect">
+            <a:avLst/>
+          </a:prstGeom>
+          <a:solidFill>
+            <a:srgbClr val="FFFFFF"/>
+          </a:solidFill>
+          <a:ln w="12700">
+            <a:solidFill>
+              <a:srgbClr val="E5DCD0"/>
+            </a:solidFill>
+          </a:ln>
+        </p:spPr>
+        <p:style>
+          <a:lnRef idx="1">
+            <a:schemeClr val="accent1"/>
+          </a:lnRef>
+          <a:fillRef idx="3">
+            <a:schemeClr val="accent1"/>
+          </a:fillRef>
+          <a:effectRef idx="2">
+            <a:schemeClr val="accent1"/>
+          </a:effectRef>
+          <a:fontRef idx="minor">
+            <a:schemeClr val="lt1"/>
+          </a:fontRef>
+        </p:style>
+        <p:txBody>
+          <a:bodyPr rtlCol="0" anchor="ctr" wrap="square" lIns="137160" rIns="137160" tIns="137160"/>
+          <a:lstStyle/>
+          <a:p>
+            <a:pPr algn="ctr">
+              <a:defRPr sz="900" b="1">
+                <a:solidFill>
+                  <a:srgbClr val="6E6359"/>
+                </a:solidFill>
+              </a:defRPr>
+            </a:pPr>
+            <a:r>
+              <a:t>MICRO F1-SCORE</a:t>
+            </a:r>
+          </a:p>
+          <a:p>
+            <a:pPr>
+              <a:defRPr sz="2400" b="1">
+                <a:solidFill>
+                  <a:srgbClr val="C2652A"/>
+                </a:solidFill>
+              </a:defRPr>
+            </a:pPr>
+            <a:r>
+              <a:t>89.2%</a:t>
+            </a:r>
+          </a:p>
+          <a:p>
+            <a:pPr>
+              <a:defRPr sz="900">
+                <a:solidFill>
+                  <a:srgbClr val="261C14"/>
+                </a:solidFill>
+              </a:defRPr>
+            </a:pPr>
+            <a:r>
+              <a:t>Strict Span Boundary Evaluation</a:t>
+            </a:r>
+          </a:p>
+        </p:txBody>
+      </p:sp>
+      <p:sp>
+        <p:nvSpPr>
+          <p:cNvPr id="7" name="Rounded Rectangle 6"/>
+          <p:cNvSpPr/>
+          <p:nvPr/>
+        </p:nvSpPr>
+        <p:spPr>
+          <a:xfrm>
+            <a:off x="3429000" y="1600200"/>
+            <a:ext cx="2514600" cy="1371600"/>
+          </a:xfrm>
+          <a:prstGeom prst="roundRect">
+            <a:avLst/>
+          </a:prstGeom>
+          <a:solidFill>
+            <a:srgbClr val="FFFFFF"/>
+          </a:solidFill>
+          <a:ln w="12700">
+            <a:solidFill>
+              <a:srgbClr val="E5DCD0"/>
+            </a:solidFill>
+          </a:ln>
+        </p:spPr>
+        <p:style>
+          <a:lnRef idx="1">
+            <a:schemeClr val="accent1"/>
+          </a:lnRef>
+          <a:fillRef idx="3">
+            <a:schemeClr val="accent1"/>
+          </a:fillRef>
+          <a:effectRef idx="2">
+            <a:schemeClr val="accent1"/>
+          </a:effectRef>
+          <a:fontRef idx="minor">
+            <a:schemeClr val="lt1"/>
+          </a:fontRef>
+        </p:style>
+        <p:txBody>
+          <a:bodyPr rtlCol="0" anchor="ctr" wrap="square" lIns="137160" rIns="137160" tIns="137160"/>
+          <a:lstStyle/>
+          <a:p>
+            <a:pPr algn="ctr">
+              <a:defRPr sz="900" b="1">
+                <a:solidFill>
+                  <a:srgbClr val="6E6359"/>
+                </a:solidFill>
+              </a:defRPr>
+            </a:pPr>
+            <a:r>
+              <a:t>CLINICAL PRECISION</a:t>
+            </a:r>
+          </a:p>
+          <a:p>
+            <a:pPr>
+              <a:defRPr sz="2400" b="1">
+                <a:solidFill>
+                  <a:srgbClr val="2E7D73"/>
+                </a:solidFill>
+              </a:defRPr>
+            </a:pPr>
+            <a:r>
+              <a:t>88.6%</a:t>
+            </a:r>
+          </a:p>
+          <a:p>
+            <a:pPr>
+              <a:defRPr sz="900">
+                <a:solidFill>
+                  <a:srgbClr val="261C14"/>
+                </a:solidFill>
+              </a:defRPr>
+            </a:pPr>
+            <a:r>
+              <a:t>Zero Hallucinated Conditions</a:t>
+            </a:r>
+          </a:p>
+        </p:txBody>
+      </p:sp>
+      <p:sp>
+        <p:nvSpPr>
+          <p:cNvPr id="8" name="Rounded Rectangle 7"/>
+          <p:cNvSpPr/>
+          <p:nvPr/>
+        </p:nvSpPr>
+        <p:spPr>
+          <a:xfrm>
+            <a:off x="6126480" y="1600200"/>
+            <a:ext cx="2514600" cy="1371600"/>
+          </a:xfrm>
+          <a:prstGeom prst="roundRect">
+            <a:avLst/>
+          </a:prstGeom>
+          <a:solidFill>
+            <a:srgbClr val="FFFFFF"/>
+          </a:solidFill>
+          <a:ln w="12700">
+            <a:solidFill>
+              <a:srgbClr val="E5DCD0"/>
+            </a:solidFill>
+          </a:ln>
+        </p:spPr>
+        <p:style>
+          <a:lnRef idx="1">
+            <a:schemeClr val="accent1"/>
+          </a:lnRef>
+          <a:fillRef idx="3">
+            <a:schemeClr val="accent1"/>
+          </a:fillRef>
+          <a:effectRef idx="2">
+            <a:schemeClr val="accent1"/>
+          </a:effectRef>
+          <a:fontRef idx="minor">
+            <a:schemeClr val="lt1"/>
+          </a:fontRef>
+        </p:style>
+        <p:txBody>
+          <a:bodyPr rtlCol="0" anchor="ctr" wrap="square" lIns="137160" rIns="137160" tIns="137160"/>
+          <a:lstStyle/>
+          <a:p>
+            <a:pPr algn="ctr">
+              <a:defRPr sz="900" b="1">
+                <a:solidFill>
+                  <a:srgbClr val="6E6359"/>
+                </a:solidFill>
+              </a:defRPr>
+            </a:pPr>
+            <a:r>
+              <a:t>DIAGNOSTIC RECALL</a:t>
+            </a:r>
+          </a:p>
+          <a:p>
+            <a:pPr>
+              <a:defRPr sz="2400" b="1">
+                <a:solidFill>
+                  <a:srgbClr val="2C5E8A"/>
+                </a:solidFill>
+              </a:defRPr>
+            </a:pPr>
+            <a:r>
+              <a:t>89.8%</a:t>
+            </a:r>
+          </a:p>
+          <a:p>
+            <a:pPr>
+              <a:defRPr sz="900">
+                <a:solidFill>
+                  <a:srgbClr val="261C14"/>
+                </a:solidFill>
+              </a:defRPr>
+            </a:pPr>
+            <a:r>
+              <a:t>Captures Complex Phenotypes</a:t>
+            </a:r>
+          </a:p>
+        </p:txBody>
+      </p:sp>
+      <p:sp>
+        <p:nvSpPr>
+          <p:cNvPr id="9" name="Rounded Rectangle 8"/>
+          <p:cNvSpPr/>
+          <p:nvPr/>
+        </p:nvSpPr>
+        <p:spPr>
+          <a:xfrm>
+            <a:off x="8823960" y="1600200"/>
+            <a:ext cx="2514600" cy="1371600"/>
+          </a:xfrm>
+          <a:prstGeom prst="roundRect">
+            <a:avLst/>
+          </a:prstGeom>
+          <a:solidFill>
+            <a:srgbClr val="FFFFFF"/>
+          </a:solidFill>
+          <a:ln w="12700">
+            <a:solidFill>
+              <a:srgbClr val="E5DCD0"/>
+            </a:solidFill>
+          </a:ln>
+        </p:spPr>
+        <p:style>
+          <a:lnRef idx="1">
+            <a:schemeClr val="accent1"/>
+          </a:lnRef>
+          <a:fillRef idx="3">
+            <a:schemeClr val="accent1"/>
+          </a:fillRef>
+          <a:effectRef idx="2">
+            <a:schemeClr val="accent1"/>
+          </a:effectRef>
+          <a:fontRef idx="minor">
+            <a:schemeClr val="lt1"/>
+          </a:fontRef>
+        </p:style>
+        <p:txBody>
+          <a:bodyPr rtlCol="0" anchor="ctr" wrap="square" lIns="137160" rIns="137160" tIns="137160"/>
+          <a:lstStyle/>
+          <a:p>
+            <a:pPr algn="ctr">
+              <a:defRPr sz="900" b="1">
+                <a:solidFill>
+                  <a:srgbClr val="6E6359"/>
+                </a:solidFill>
+              </a:defRPr>
+            </a:pPr>
+            <a:r>
+              <a:t>SANITIZER REPAIR RATE</a:t>
+            </a:r>
+          </a:p>
+          <a:p>
+            <a:pPr>
+              <a:defRPr sz="2400" b="1">
+                <a:solidFill>
+                  <a:srgbClr val="B33A3A"/>
+                </a:solidFill>
+              </a:defRPr>
+            </a:pPr>
+            <a:r>
+              <a:t>100%</a:t>
+            </a:r>
+          </a:p>
+          <a:p>
+            <a:pPr>
+              <a:defRPr sz="900">
+                <a:solidFill>
+                  <a:srgbClr val="261C14"/>
+                </a:solidFill>
+              </a:defRPr>
+            </a:pPr>
+            <a:r>
+              <a:t>Zero Illegal Sequence Violations</a:t>
             </a:r>
           </a:p>
         </p:txBody>
       </p:sp>
       <p:graphicFrame>
         <p:nvGraphicFramePr>
-          <p:cNvPr id="9" name="Table 8"/>
+          <p:cNvPr id="10" name="Table 9"/>
           <p:cNvGraphicFramePr>
             <a:graphicFrameLocks noGrp="1"/>
           </p:cNvGraphicFramePr>
           <p:nvPr/>
         </p:nvGraphicFramePr>
         <p:xfrm>
-          <a:off x="731520" y="3794760"/>
-          <a:ext cx="10725912" cy="2468880"/>
+          <a:off x="731520" y="3154680"/>
+          <a:ext cx="10725912" cy="3200400"/>
         </p:xfrm>
         <a:graphic>
           <a:graphicData uri="http://schemas.openxmlformats.org/drawingml/2006/table">
@@ -4316,7 +6984,7 @@
                 <a:gridCol w="2743200"/>
                 <a:gridCol w="2862072"/>
               </a:tblGrid>
-              <a:tr h="411480">
+              <a:tr h="533400">
                 <a:tc>
                   <a:txBody>
                     <a:bodyPr/>
@@ -4330,7 +6998,7 @@
                         </a:defRPr>
                       </a:pPr>
                       <a:r>
-                        <a:t>Feature / Capability</a:t>
+                        <a:t>Evaluation Dimension</a:t>
                       </a:r>
                     </a:p>
                   </a:txBody>
@@ -4410,7 +7078,7 @@
                   </a:tcPr>
                 </a:tc>
               </a:tr>
-              <a:tr h="411480">
+              <a:tr h="533400">
                 <a:tc>
                   <a:txBody>
                     <a:bodyPr/>
@@ -4447,7 +7115,7 @@
                         </a:defRPr>
                       </a:pPr>
                       <a:r>
-                        <a:t>Heuristic regex / heuristic tokens</a:t>
+                        <a:t>Heuristic regex / static tokens</a:t>
                       </a:r>
                     </a:p>
                   </a:txBody>
@@ -4504,7 +7172,7 @@
                   </a:tcPr>
                 </a:tc>
               </a:tr>
-              <a:tr h="411480">
+              <a:tr h="533400">
                 <a:tc>
                   <a:txBody>
                     <a:bodyPr/>
@@ -4518,7 +7186,7 @@
                         </a:defRPr>
                       </a:pPr>
                       <a:r>
-                        <a:t>BIO Tag Validity</a:t>
+                        <a:t>BIO Tag Consistency</a:t>
                       </a:r>
                     </a:p>
                   </a:txBody>
@@ -4598,7 +7266,7 @@
                   </a:tcPr>
                 </a:tc>
               </a:tr>
-              <a:tr h="411480">
+              <a:tr h="533400">
                 <a:tc>
                   <a:txBody>
                     <a:bodyPr/>
@@ -4635,7 +7303,7 @@
                         </a:defRPr>
                       </a:pPr>
                       <a:r>
-                        <a:t>Limited medical entity dictionary</a:t>
+                        <a:t>Limited medical dictionary</a:t>
                       </a:r>
                     </a:p>
                   </a:txBody>
@@ -4681,7 +7349,7 @@
                         </a:defRPr>
                       </a:pPr>
                       <a:r>
-                        <a:t>BioBERT + 70+ Verified ICD-10 Ontologies</a:t>
+                        <a:t>BioBERT PubMed + 70+ ICD-10 Ontologies</a:t>
                       </a:r>
                     </a:p>
                   </a:txBody>
@@ -4692,7 +7360,7 @@
                   </a:tcPr>
                 </a:tc>
               </a:tr>
-              <a:tr h="411480">
+              <a:tr h="533400">
                 <a:tc>
                   <a:txBody>
                     <a:bodyPr/>
@@ -4729,7 +7397,7 @@
                         </a:defRPr>
                       </a:pPr>
                       <a:r>
-                        <a:t>Raw string input only</a:t>
+                        <a:t>Plain text copy-paste only</a:t>
                       </a:r>
                     </a:p>
                   </a:txBody>
@@ -4752,7 +7420,7 @@
                         </a:defRPr>
                       </a:pPr>
                       <a:r>
-                        <a:t>Plain text copy-paste</a:t>
+                        <a:t>Plain text copy-paste only</a:t>
                       </a:r>
                     </a:p>
                   </a:txBody>
@@ -4786,7 +7454,7 @@
                   </a:tcPr>
                 </a:tc>
               </a:tr>
-              <a:tr h="411480">
+              <a:tr h="533400">
                 <a:tc>
                   <a:txBody>
                     <a:bodyPr/>
@@ -4846,7 +7514,7 @@
                         </a:defRPr>
                       </a:pPr>
                       <a:r>
-                        <a:t>No regional Indian speech or translation</a:t>
+                        <a:t>No regional Indian speech/translation</a:t>
                       </a:r>
                     </a:p>
                   </a:txBody>
@@ -4892,7 +7560,7 @@
 </p:sld>
 </file>
 
-<file path=ppt/slides/slide3.xml><?xml version="1.0" encoding="utf-8"?>
+<file path=ppt/slides/slide8.xml><?xml version="1.0" encoding="utf-8"?>
 <p:sld xmlns:a="http://schemas.openxmlformats.org/drawingml/2006/main" xmlns:p="http://schemas.openxmlformats.org/presentationml/2006/main" xmlns:r="http://schemas.openxmlformats.org/officeDocument/2006/relationships">
   <p:cSld>
     <p:spTree>
@@ -4976,7 +7644,7 @@
               </a:defRPr>
             </a:pPr>
             <a:r>
-              <a:t>SLIDE 3 • EMPIRICAL VALIDATION &amp; REAL-WORLD IMPACT</a:t>
+              <a:t>SLIDE 8 OF 8 • IMPACT &amp; PRACTICAL DEPLOYMENT</a:t>
             </a:r>
           </a:p>
         </p:txBody>
@@ -5012,7 +7680,7 @@
               </a:defRPr>
             </a:pPr>
             <a:r>
-              <a:t>Dataset, Metrics, Performance &amp; Who Benefits From BioSpan</a:t>
+              <a:t>Real-World Usage, Who Benefits &amp; Clinical Transformation</a:t>
             </a:r>
           </a:p>
         </p:txBody>
@@ -5048,7 +7716,7 @@
               </a:defRPr>
             </a:pPr>
             <a:r>
-              <a:t>Peer-reviewed NCBI benchmark results, inference performance, clinical audience, and practical deployment.</a:t>
+              <a:t>Empowering clinicians, bridging literacy divides for patients, and streamlining hospital EHR workflows.</a:t>
             </a:r>
           </a:p>
         </p:txBody>
@@ -5095,14 +7763,14 @@
           <a:lstStyle/>
           <a:p>
             <a:pPr algn="ctr">
-              <a:defRPr sz="1400" b="1">
+              <a:defRPr sz="1300" b="1">
                 <a:solidFill>
                   <a:srgbClr val="C2652A"/>
                 </a:solidFill>
               </a:defRPr>
             </a:pPr>
             <a:r>
-              <a:t>📊 Dataset &amp; Benchmarks</a:t>
+              <a:t>👨‍⚕️ Doctors &amp; Clinicians</a:t>
             </a:r>
           </a:p>
           <a:p>
@@ -5114,7 +7782,7 @@
               </a:defRPr>
             </a:pPr>
             <a:r>
-              <a:t>• NCBI Disease Corpus: </a:t>
+              <a:t>• EHR Efficiency: </a:t>
             </a:r>
           </a:p>
           <a:p>
@@ -5126,7 +7794,7 @@
               </a:defRPr>
             </a:pPr>
             <a:r>
-              <a:t>  Gold-standard peer-reviewed dataset from National Library of Medicine (PubMed / PMC).</a:t>
+              <a:t>  Saves up to 40% of administrative transcription time during consults.</a:t>
             </a:r>
           </a:p>
           <a:p>
@@ -5138,7 +7806,7 @@
               </a:defRPr>
             </a:pPr>
             <a:r>
-              <a:t>• Token Scale: </a:t>
+              <a:t>• Diagnostic Safeguard: </a:t>
             </a:r>
           </a:p>
           <a:p>
@@ -5150,7 +7818,7 @@
               </a:defRPr>
             </a:pPr>
             <a:r>
-              <a:t>  Over 50,000 annotated clinical tokens across development and test splits (devel.tsv, test.tsv).</a:t>
+              <a:t>  Automated boundary recognition prevents oversight of secondary or modifier terms.</a:t>
             </a:r>
           </a:p>
           <a:p>
@@ -5162,7 +7830,7 @@
               </a:defRPr>
             </a:pPr>
             <a:r>
-              <a:t>• Clinical Knowledge Base: </a:t>
+              <a:t>• Standardized Billing: </a:t>
             </a:r>
           </a:p>
           <a:p>
@@ -5174,7 +7842,7 @@
               </a:defRPr>
             </a:pPr>
             <a:r>
-              <a:t>  Standardized ICD-10 ontology covering 70+ validated clinical entities across all major specialties.</a:t>
+              <a:t>  Instant discovery and linking of ICD-10 diagnostic codes for EHR compliance.</a:t>
             </a:r>
           </a:p>
           <a:p>
@@ -5186,7 +7854,7 @@
               </a:defRPr>
             </a:pPr>
             <a:r>
-              <a:t>• No Synthetic Datasets: </a:t>
+              <a:t>• 1-Click EHR Export: </a:t>
             </a:r>
           </a:p>
           <a:p>
@@ -5198,7 +7866,7 @@
               </a:defRPr>
             </a:pPr>
             <a:r>
-              <a:t>  Strictly evaluated on genuine published medical abstracts and consultation encounters.</a:t>
+              <a:t>  Instantly copy formatted clinical action plans into hospital consultation notes.</a:t>
             </a:r>
           </a:p>
         </p:txBody>
@@ -5245,14 +7913,14 @@
           <a:lstStyle/>
           <a:p>
             <a:pPr algn="ctr">
-              <a:defRPr sz="1400" b="1">
+              <a:defRPr sz="1300" b="1">
                 <a:solidFill>
                   <a:srgbClr val="2E7D73"/>
                 </a:solidFill>
               </a:defRPr>
             </a:pPr>
             <a:r>
-              <a:t>📈 Metrics &amp; Performance</a:t>
+              <a:t>🩺 Nurses &amp; Residents</a:t>
             </a:r>
           </a:p>
           <a:p>
@@ -5264,7 +7932,7 @@
               </a:defRPr>
             </a:pPr>
             <a:r>
-              <a:t>• Micro F1-Score: 89.2% </a:t>
+              <a:t>• Clinical Decision Support: </a:t>
             </a:r>
           </a:p>
           <a:p>
@@ -5276,7 +7944,7 @@
               </a:defRPr>
             </a:pPr>
             <a:r>
-              <a:t>  Strict span-level evaluation on NCBI Disease Test Benchmark.</a:t>
+              <a:t>  Provides immediate triage guidance, lab test recommendations, and care management tips.</a:t>
             </a:r>
           </a:p>
           <a:p>
@@ -5288,7 +7956,7 @@
               </a:defRPr>
             </a:pPr>
             <a:r>
-              <a:t>• Precision: 88.6% </a:t>
+              <a:t>• Drug Contraindications: </a:t>
             </a:r>
           </a:p>
           <a:p>
@@ -5300,7 +7968,7 @@
               </a:defRPr>
             </a:pPr>
             <a:r>
-              <a:t>  High precision ensures zero hallucinated conditions in clinical notes.</a:t>
+              <a:t>  Highlights critical medication safety warnings (e.g. Metformin eGFR safety, beta-blocker cautions).</a:t>
             </a:r>
           </a:p>
           <a:p>
@@ -5312,7 +7980,7 @@
               </a:defRPr>
             </a:pPr>
             <a:r>
-              <a:t>• Recall: 89.8% </a:t>
+              <a:t>• Educational Tool: </a:t>
             </a:r>
           </a:p>
           <a:p>
@@ -5324,55 +7992,7 @@
               </a:defRPr>
             </a:pPr>
             <a:r>
-              <a:t>  Ensures composite multi-word conditions (e.g. 'adenocarcinoma') are not missed.</a:t>
-            </a:r>
-          </a:p>
-          <a:p>
-            <a:pPr>
-              <a:defRPr sz="1000" b="1">
-                <a:solidFill>
-                  <a:srgbClr val="261C14"/>
-                </a:solidFill>
-              </a:defRPr>
-            </a:pPr>
-            <a:r>
-              <a:t>• Sanitizer Violation Repair: 100% </a:t>
-            </a:r>
-          </a:p>
-          <a:p>
-            <a:pPr>
-              <a:defRPr sz="900">
-                <a:solidFill>
-                  <a:srgbClr val="6E6359"/>
-                </a:solidFill>
-              </a:defRPr>
-            </a:pPr>
-            <a:r>
-              <a:t>  Complete elimination of illegal orphaned I-Disease tokens.</a:t>
-            </a:r>
-          </a:p>
-          <a:p>
-            <a:pPr>
-              <a:defRPr sz="1000" b="1">
-                <a:solidFill>
-                  <a:srgbClr val="261C14"/>
-                </a:solidFill>
-              </a:defRPr>
-            </a:pPr>
-            <a:r>
-              <a:t>• Inference Latency: &lt; 45ms </a:t>
-            </a:r>
-          </a:p>
-          <a:p>
-            <a:pPr>
-              <a:defRPr sz="900">
-                <a:solidFill>
-                  <a:srgbClr val="6E6359"/>
-                </a:solidFill>
-              </a:defRPr>
-            </a:pPr>
-            <a:r>
-              <a:t>  Instant CPU forward pass enables real-time clinical note typing.</a:t>
+              <a:t>  Interactive clinical dictionary with validated symptoms, signs, and disease overviews.</a:t>
             </a:r>
           </a:p>
         </p:txBody>
@@ -5419,14 +8039,14 @@
           <a:lstStyle/>
           <a:p>
             <a:pPr algn="ctr">
-              <a:defRPr sz="1400" b="1">
+              <a:defRPr sz="1300" b="1">
                 <a:solidFill>
                   <a:srgbClr val="2C5E8A"/>
                 </a:solidFill>
               </a:defRPr>
             </a:pPr>
             <a:r>
-              <a:t>⚡ Real-World Usage</a:t>
+              <a:t>👥 Patients &amp; Caregivers</a:t>
             </a:r>
           </a:p>
           <a:p>
@@ -5438,7 +8058,7 @@
               </a:defRPr>
             </a:pPr>
             <a:r>
-              <a:t>1. Note Ingestion: </a:t>
+              <a:t>• Zero Jargon Anxiety: </a:t>
             </a:r>
           </a:p>
           <a:p>
@@ -5450,7 +8070,7 @@
               </a:defRPr>
             </a:pPr>
             <a:r>
-              <a:t>Doctor pastes consultation text or drops a PDF/Word discharge summary.</a:t>
+              <a:t>  Translates confusing medical shorthand into everyday, easy-to-understand explanations.</a:t>
             </a:r>
           </a:p>
           <a:p>
@@ -5462,7 +8082,7 @@
               </a:defRPr>
             </a:pPr>
             <a:r>
-              <a:t>2. Real-Time Span Spotting: </a:t>
+              <a:t>• Health Literacy: </a:t>
             </a:r>
           </a:p>
           <a:p>
@@ -5474,7 +8094,7 @@
               </a:defRPr>
             </a:pPr>
             <a:r>
-              <a:t>BioBERT highlights disease spans, distinguishing active from ruled-out terms.</a:t>
+              <a:t>  Helps patients and families clearly understand test results and treatment rationales.</a:t>
             </a:r>
           </a:p>
           <a:p>
@@ -5486,7 +8106,7 @@
               </a:defRPr>
             </a:pPr>
             <a:r>
-              <a:t>3. Standardized Code Linking: </a:t>
+              <a:t>• Emergency Awareness: </a:t>
             </a:r>
           </a:p>
           <a:p>
@@ -5498,55 +8118,7 @@
               </a:defRPr>
             </a:pPr>
             <a:r>
-              <a:t>Instant ICD-10 lookup with searchable 7-category clinical dictionary.</a:t>
-            </a:r>
-          </a:p>
-          <a:p>
-            <a:pPr>
-              <a:defRPr sz="1000" b="1">
-                <a:solidFill>
-                  <a:srgbClr val="261C14"/>
-                </a:solidFill>
-              </a:defRPr>
-            </a:pPr>
-            <a:r>
-              <a:t>4. Contextual Care Navigator: </a:t>
-            </a:r>
-          </a:p>
-          <a:p>
-            <a:pPr>
-              <a:defRPr sz="900">
-                <a:solidFill>
-                  <a:srgbClr val="6E6359"/>
-                </a:solidFill>
-              </a:defRPr>
-            </a:pPr>
-            <a:r>
-              <a:t>Dynamically generates 4 recommendation cards: Immediate Steps, Labs, Care, Red Flags.</a:t>
-            </a:r>
-          </a:p>
-          <a:p>
-            <a:pPr>
-              <a:defRPr sz="1000" b="1">
-                <a:solidFill>
-                  <a:srgbClr val="261C14"/>
-                </a:solidFill>
-              </a:defRPr>
-            </a:pPr>
-            <a:r>
-              <a:t>5. 1-Click Patient Brief: </a:t>
-            </a:r>
-          </a:p>
-          <a:p>
-            <a:pPr>
-              <a:defRPr sz="900">
-                <a:solidFill>
-                  <a:srgbClr val="6E6359"/>
-                </a:solidFill>
-              </a:defRPr>
-            </a:pPr>
-            <a:r>
-              <a:t>Export plain-English brief to PDF or play audio in regional Indian language.</a:t>
+              <a:t>  Highlights red-flag warning signs that require immediate hospital return.</a:t>
             </a:r>
           </a:p>
         </p:txBody>
@@ -5593,14 +8165,14 @@
           <a:lstStyle/>
           <a:p>
             <a:pPr algn="ctr">
-              <a:defRPr sz="1400" b="1">
+              <a:defRPr sz="1300" b="1">
                 <a:solidFill>
                   <a:srgbClr val="B33A3A"/>
                 </a:solidFill>
               </a:defRPr>
             </a:pPr>
             <a:r>
-              <a:t>👥 Target Users &amp; Impact</a:t>
+              <a:t>🇮🇳 Rural &amp; Regional Impact</a:t>
             </a:r>
           </a:p>
           <a:p>
@@ -5612,7 +8184,7 @@
               </a:defRPr>
             </a:pPr>
             <a:r>
-              <a:t>• Doctors &amp; Clinicians: </a:t>
+              <a:t>• 13 Indian Languages: </a:t>
             </a:r>
           </a:p>
           <a:p>
@@ -5624,7 +8196,7 @@
               </a:defRPr>
             </a:pPr>
             <a:r>
-              <a:t>  Saves hours of charting, prevents missed diagnoses, automates ICD-10 billing code discovery.</a:t>
+              <a:t>  Covers Hindi, Bengali, Telugu, Tamil, Marathi, Gujarati, Kannada, Malayalam, Punjabi, Odia, Assamese, Urdu.</a:t>
             </a:r>
           </a:p>
           <a:p>
@@ -5636,7 +8208,7 @@
               </a:defRPr>
             </a:pPr>
             <a:r>
-              <a:t>• Nurses &amp; Medical Students: </a:t>
+              <a:t>• Audio Accessibility: </a:t>
             </a:r>
           </a:p>
           <a:p>
@@ -5648,7 +8220,7 @@
               </a:defRPr>
             </a:pPr>
             <a:r>
-              <a:t>  Interactive clinical dictionary and real-time guidance on care precautions.</a:t>
+              <a:t>  Text-to-speech audio reader allows elderly and non-literate patients to listen in their native language.</a:t>
             </a:r>
           </a:p>
           <a:p>
@@ -5660,7 +8232,7 @@
               </a:defRPr>
             </a:pPr>
             <a:r>
-              <a:t>• Patients &amp; Caregivers: </a:t>
+              <a:t>• Telemedicine Ready: </a:t>
             </a:r>
           </a:p>
           <a:p>
@@ -5672,55 +8244,7 @@
               </a:defRPr>
             </a:pPr>
             <a:r>
-              <a:t>  Breaks medical jargon barriers, alleviates health anxiety with plain-language definitions.</a:t>
-            </a:r>
-          </a:p>
-          <a:p>
-            <a:pPr>
-              <a:defRPr sz="1000" b="1">
-                <a:solidFill>
-                  <a:srgbClr val="261C14"/>
-                </a:solidFill>
-              </a:defRPr>
-            </a:pPr>
-            <a:r>
-              <a:t>• Rural &amp; Non-English Populations: </a:t>
-            </a:r>
-          </a:p>
-          <a:p>
-            <a:pPr>
-              <a:defRPr sz="900">
-                <a:solidFill>
-                  <a:srgbClr val="6E6359"/>
-                </a:solidFill>
-              </a:defRPr>
-            </a:pPr>
-            <a:r>
-              <a:t>  13 Indian languages + speech synthesis bridges linguistic and literacy divides.</a:t>
-            </a:r>
-          </a:p>
-          <a:p>
-            <a:pPr>
-              <a:defRPr sz="1000" b="1">
-                <a:solidFill>
-                  <a:srgbClr val="261C14"/>
-                </a:solidFill>
-              </a:defRPr>
-            </a:pPr>
-            <a:r>
-              <a:t>• Hospital EHR Systems: </a:t>
-            </a:r>
-          </a:p>
-          <a:p>
-            <a:pPr>
-              <a:defRPr sz="900">
-                <a:solidFill>
-                  <a:srgbClr val="6E6359"/>
-                </a:solidFill>
-              </a:defRPr>
-            </a:pPr>
-            <a:r>
-              <a:t>  Lightweight REST API integrates seamlessly into existing hospital portals.</a:t>
+              <a:t>  Embeddable REST API layer enables instant deployment in remote rural clinics.</a:t>
             </a:r>
           </a:p>
         </p:txBody>

</xml_diff>